<commit_message>
Fix nested repository issue and track folder normally
</commit_message>
<xml_diff>
--- a/Lab_report/bá0_cáo_llm_nwdaf.pptx
+++ b/Lab_report/bá0_cáo_llm_nwdaf.pptx
@@ -4,6 +4,9 @@
   <p:sldMasterIdLst>
     <p:sldMasterId id="2147483648" r:id="rId1"/>
   </p:sldMasterIdLst>
+  <p:notesMasterIdLst>
+    <p:notesMasterId r:id="rId20"/>
+  </p:notesMasterIdLst>
   <p:sldIdLst>
     <p:sldId id="256" r:id="rId2"/>
     <p:sldId id="264" r:id="rId3"/>
@@ -14,6 +17,15 @@
     <p:sldId id="261" r:id="rId8"/>
     <p:sldId id="262" r:id="rId9"/>
     <p:sldId id="263" r:id="rId10"/>
+    <p:sldId id="265" r:id="rId11"/>
+    <p:sldId id="267" r:id="rId12"/>
+    <p:sldId id="268" r:id="rId13"/>
+    <p:sldId id="269" r:id="rId14"/>
+    <p:sldId id="270" r:id="rId15"/>
+    <p:sldId id="271" r:id="rId16"/>
+    <p:sldId id="272" r:id="rId17"/>
+    <p:sldId id="273" r:id="rId18"/>
+    <p:sldId id="274" r:id="rId19"/>
   </p:sldIdLst>
   <p:sldSz cx="12192000" cy="6858000"/>
   <p:notesSz cx="6858000" cy="9144000"/>
@@ -112,7 +124,362 @@
       </a:defRPr>
     </a:lvl9pPr>
   </p:defaultTextStyle>
+  <p:extLst>
+    <p:ext uri="{EFAFB233-063F-42B5-8137-9DF3F51BA10A}">
+      <p15:sldGuideLst xmlns:p15="http://schemas.microsoft.com/office/powerpoint/2012/main"/>
+    </p:ext>
+  </p:extLst>
 </p:presentation>
+</file>
+
+<file path=ppt/notesMasters/notesMaster1.xml><?xml version="1.0" encoding="utf-8"?>
+<p:notesMaster xmlns:a="http://schemas.openxmlformats.org/drawingml/2006/main" xmlns:r="http://schemas.openxmlformats.org/officeDocument/2006/relationships" xmlns:p="http://schemas.openxmlformats.org/presentationml/2006/main">
+  <p:cSld>
+    <p:bg>
+      <p:bgRef idx="1001">
+        <a:schemeClr val="bg1"/>
+      </p:bgRef>
+    </p:bg>
+    <p:spTree>
+      <p:nvGrpSpPr>
+        <p:cNvPr id="1" name=""/>
+        <p:cNvGrpSpPr/>
+        <p:nvPr/>
+      </p:nvGrpSpPr>
+      <p:grpSpPr>
+        <a:xfrm>
+          <a:off x="0" y="0"/>
+          <a:ext cx="0" cy="0"/>
+          <a:chOff x="0" y="0"/>
+          <a:chExt cx="0" cy="0"/>
+        </a:xfrm>
+      </p:grpSpPr>
+      <p:sp>
+        <p:nvSpPr>
+          <p:cNvPr id="2" name="Header Placeholder 1"/>
+          <p:cNvSpPr>
+            <a:spLocks noGrp="1"/>
+          </p:cNvSpPr>
+          <p:nvPr>
+            <p:ph type="hdr" sz="quarter"/>
+          </p:nvPr>
+        </p:nvSpPr>
+        <p:spPr>
+          <a:xfrm>
+            <a:off x="0" y="0"/>
+            <a:ext cx="2971800" cy="458788"/>
+          </a:xfrm>
+          <a:prstGeom prst="rect">
+            <a:avLst/>
+          </a:prstGeom>
+        </p:spPr>
+        <p:txBody>
+          <a:bodyPr vert="horz" lIns="91440" tIns="45720" rIns="91440" bIns="45720" rtlCol="0"/>
+          <a:lstStyle>
+            <a:lvl1pPr algn="l">
+              <a:defRPr sz="1200"/>
+            </a:lvl1pPr>
+          </a:lstStyle>
+          <a:p>
+            <a:endParaRPr lang="en-GB"/>
+          </a:p>
+        </p:txBody>
+      </p:sp>
+      <p:sp>
+        <p:nvSpPr>
+          <p:cNvPr id="3" name="Date Placeholder 2"/>
+          <p:cNvSpPr>
+            <a:spLocks noGrp="1"/>
+          </p:cNvSpPr>
+          <p:nvPr>
+            <p:ph type="dt" idx="1"/>
+          </p:nvPr>
+        </p:nvSpPr>
+        <p:spPr>
+          <a:xfrm>
+            <a:off x="3884613" y="0"/>
+            <a:ext cx="2971800" cy="458788"/>
+          </a:xfrm>
+          <a:prstGeom prst="rect">
+            <a:avLst/>
+          </a:prstGeom>
+        </p:spPr>
+        <p:txBody>
+          <a:bodyPr vert="horz" lIns="91440" tIns="45720" rIns="91440" bIns="45720" rtlCol="0"/>
+          <a:lstStyle>
+            <a:lvl1pPr algn="r">
+              <a:defRPr sz="1200"/>
+            </a:lvl1pPr>
+          </a:lstStyle>
+          <a:p>
+            <a:fld id="{68B21D33-7199-44D7-925F-F4DD652B999F}" type="datetimeFigureOut">
+              <a:rPr lang="en-GB" smtClean="0"/>
+              <a:t>20/10/2026</a:t>
+            </a:fld>
+            <a:endParaRPr lang="en-GB"/>
+          </a:p>
+        </p:txBody>
+      </p:sp>
+      <p:sp>
+        <p:nvSpPr>
+          <p:cNvPr id="4" name="Slide Image Placeholder 3"/>
+          <p:cNvSpPr>
+            <a:spLocks noGrp="1" noRot="1" noChangeAspect="1"/>
+          </p:cNvSpPr>
+          <p:nvPr>
+            <p:ph type="sldImg" idx="2"/>
+          </p:nvPr>
+        </p:nvSpPr>
+        <p:spPr>
+          <a:xfrm>
+            <a:off x="685800" y="1143000"/>
+            <a:ext cx="5486400" cy="3086100"/>
+          </a:xfrm>
+          <a:prstGeom prst="rect">
+            <a:avLst/>
+          </a:prstGeom>
+          <a:noFill/>
+          <a:ln w="12700">
+            <a:solidFill>
+              <a:prstClr val="black"/>
+            </a:solidFill>
+          </a:ln>
+        </p:spPr>
+        <p:txBody>
+          <a:bodyPr vert="horz" lIns="91440" tIns="45720" rIns="91440" bIns="45720" rtlCol="0" anchor="ctr"/>
+          <a:lstStyle/>
+          <a:p>
+            <a:endParaRPr lang="en-GB"/>
+          </a:p>
+        </p:txBody>
+      </p:sp>
+      <p:sp>
+        <p:nvSpPr>
+          <p:cNvPr id="5" name="Notes Placeholder 4"/>
+          <p:cNvSpPr>
+            <a:spLocks noGrp="1"/>
+          </p:cNvSpPr>
+          <p:nvPr>
+            <p:ph type="body" sz="quarter" idx="3"/>
+          </p:nvPr>
+        </p:nvSpPr>
+        <p:spPr>
+          <a:xfrm>
+            <a:off x="685800" y="4400550"/>
+            <a:ext cx="5486400" cy="3600450"/>
+          </a:xfrm>
+          <a:prstGeom prst="rect">
+            <a:avLst/>
+          </a:prstGeom>
+        </p:spPr>
+        <p:txBody>
+          <a:bodyPr vert="horz" lIns="91440" tIns="45720" rIns="91440" bIns="45720" rtlCol="0"/>
+          <a:lstStyle/>
+          <a:p>
+            <a:pPr lvl="0"/>
+            <a:r>
+              <a:rPr lang="en-US"/>
+              <a:t>Click to edit Master text styles</a:t>
+            </a:r>
+          </a:p>
+          <a:p>
+            <a:pPr lvl="1"/>
+            <a:r>
+              <a:rPr lang="en-US"/>
+              <a:t>Second level</a:t>
+            </a:r>
+          </a:p>
+          <a:p>
+            <a:pPr lvl="2"/>
+            <a:r>
+              <a:rPr lang="en-US"/>
+              <a:t>Third level</a:t>
+            </a:r>
+          </a:p>
+          <a:p>
+            <a:pPr lvl="3"/>
+            <a:r>
+              <a:rPr lang="en-US"/>
+              <a:t>Fourth level</a:t>
+            </a:r>
+          </a:p>
+          <a:p>
+            <a:pPr lvl="4"/>
+            <a:r>
+              <a:rPr lang="en-US"/>
+              <a:t>Fifth level</a:t>
+            </a:r>
+            <a:endParaRPr lang="en-GB"/>
+          </a:p>
+        </p:txBody>
+      </p:sp>
+      <p:sp>
+        <p:nvSpPr>
+          <p:cNvPr id="6" name="Footer Placeholder 5"/>
+          <p:cNvSpPr>
+            <a:spLocks noGrp="1"/>
+          </p:cNvSpPr>
+          <p:nvPr>
+            <p:ph type="ftr" sz="quarter" idx="4"/>
+          </p:nvPr>
+        </p:nvSpPr>
+        <p:spPr>
+          <a:xfrm>
+            <a:off x="0" y="8685213"/>
+            <a:ext cx="2971800" cy="458787"/>
+          </a:xfrm>
+          <a:prstGeom prst="rect">
+            <a:avLst/>
+          </a:prstGeom>
+        </p:spPr>
+        <p:txBody>
+          <a:bodyPr vert="horz" lIns="91440" tIns="45720" rIns="91440" bIns="45720" rtlCol="0" anchor="b"/>
+          <a:lstStyle>
+            <a:lvl1pPr algn="l">
+              <a:defRPr sz="1200"/>
+            </a:lvl1pPr>
+          </a:lstStyle>
+          <a:p>
+            <a:endParaRPr lang="en-GB"/>
+          </a:p>
+        </p:txBody>
+      </p:sp>
+      <p:sp>
+        <p:nvSpPr>
+          <p:cNvPr id="7" name="Slide Number Placeholder 6"/>
+          <p:cNvSpPr>
+            <a:spLocks noGrp="1"/>
+          </p:cNvSpPr>
+          <p:nvPr>
+            <p:ph type="sldNum" sz="quarter" idx="5"/>
+          </p:nvPr>
+        </p:nvSpPr>
+        <p:spPr>
+          <a:xfrm>
+            <a:off x="3884613" y="8685213"/>
+            <a:ext cx="2971800" cy="458787"/>
+          </a:xfrm>
+          <a:prstGeom prst="rect">
+            <a:avLst/>
+          </a:prstGeom>
+        </p:spPr>
+        <p:txBody>
+          <a:bodyPr vert="horz" lIns="91440" tIns="45720" rIns="91440" bIns="45720" rtlCol="0" anchor="b"/>
+          <a:lstStyle>
+            <a:lvl1pPr algn="r">
+              <a:defRPr sz="1200"/>
+            </a:lvl1pPr>
+          </a:lstStyle>
+          <a:p>
+            <a:fld id="{9A8F8E55-FEF5-4D35-89D6-9D2F655A0CD7}" type="slidenum">
+              <a:rPr lang="en-GB" smtClean="0"/>
+              <a:t>‹#›</a:t>
+            </a:fld>
+            <a:endParaRPr lang="en-GB"/>
+          </a:p>
+        </p:txBody>
+      </p:sp>
+    </p:spTree>
+    <p:extLst>
+      <p:ext uri="{BB962C8B-B14F-4D97-AF65-F5344CB8AC3E}">
+        <p14:creationId xmlns:p14="http://schemas.microsoft.com/office/powerpoint/2010/main" val="1128803006"/>
+      </p:ext>
+    </p:extLst>
+  </p:cSld>
+  <p:clrMap bg1="lt1" tx1="dk1" bg2="lt2" tx2="dk2" accent1="accent1" accent2="accent2" accent3="accent3" accent4="accent4" accent5="accent5" accent6="accent6" hlink="hlink" folHlink="folHlink"/>
+  <p:notesStyle>
+    <a:lvl1pPr marL="0" algn="l" defTabSz="914400" rtl="0" eaLnBrk="1" latinLnBrk="0" hangingPunct="1">
+      <a:defRPr sz="1200" kern="1200">
+        <a:solidFill>
+          <a:schemeClr val="tx1"/>
+        </a:solidFill>
+        <a:latin typeface="+mn-lt"/>
+        <a:ea typeface="+mn-ea"/>
+        <a:cs typeface="+mn-cs"/>
+      </a:defRPr>
+    </a:lvl1pPr>
+    <a:lvl2pPr marL="457200" algn="l" defTabSz="914400" rtl="0" eaLnBrk="1" latinLnBrk="0" hangingPunct="1">
+      <a:defRPr sz="1200" kern="1200">
+        <a:solidFill>
+          <a:schemeClr val="tx1"/>
+        </a:solidFill>
+        <a:latin typeface="+mn-lt"/>
+        <a:ea typeface="+mn-ea"/>
+        <a:cs typeface="+mn-cs"/>
+      </a:defRPr>
+    </a:lvl2pPr>
+    <a:lvl3pPr marL="914400" algn="l" defTabSz="914400" rtl="0" eaLnBrk="1" latinLnBrk="0" hangingPunct="1">
+      <a:defRPr sz="1200" kern="1200">
+        <a:solidFill>
+          <a:schemeClr val="tx1"/>
+        </a:solidFill>
+        <a:latin typeface="+mn-lt"/>
+        <a:ea typeface="+mn-ea"/>
+        <a:cs typeface="+mn-cs"/>
+      </a:defRPr>
+    </a:lvl3pPr>
+    <a:lvl4pPr marL="1371600" algn="l" defTabSz="914400" rtl="0" eaLnBrk="1" latinLnBrk="0" hangingPunct="1">
+      <a:defRPr sz="1200" kern="1200">
+        <a:solidFill>
+          <a:schemeClr val="tx1"/>
+        </a:solidFill>
+        <a:latin typeface="+mn-lt"/>
+        <a:ea typeface="+mn-ea"/>
+        <a:cs typeface="+mn-cs"/>
+      </a:defRPr>
+    </a:lvl4pPr>
+    <a:lvl5pPr marL="1828800" algn="l" defTabSz="914400" rtl="0" eaLnBrk="1" latinLnBrk="0" hangingPunct="1">
+      <a:defRPr sz="1200" kern="1200">
+        <a:solidFill>
+          <a:schemeClr val="tx1"/>
+        </a:solidFill>
+        <a:latin typeface="+mn-lt"/>
+        <a:ea typeface="+mn-ea"/>
+        <a:cs typeface="+mn-cs"/>
+      </a:defRPr>
+    </a:lvl5pPr>
+    <a:lvl6pPr marL="2286000" algn="l" defTabSz="914400" rtl="0" eaLnBrk="1" latinLnBrk="0" hangingPunct="1">
+      <a:defRPr sz="1200" kern="1200">
+        <a:solidFill>
+          <a:schemeClr val="tx1"/>
+        </a:solidFill>
+        <a:latin typeface="+mn-lt"/>
+        <a:ea typeface="+mn-ea"/>
+        <a:cs typeface="+mn-cs"/>
+      </a:defRPr>
+    </a:lvl6pPr>
+    <a:lvl7pPr marL="2743200" algn="l" defTabSz="914400" rtl="0" eaLnBrk="1" latinLnBrk="0" hangingPunct="1">
+      <a:defRPr sz="1200" kern="1200">
+        <a:solidFill>
+          <a:schemeClr val="tx1"/>
+        </a:solidFill>
+        <a:latin typeface="+mn-lt"/>
+        <a:ea typeface="+mn-ea"/>
+        <a:cs typeface="+mn-cs"/>
+      </a:defRPr>
+    </a:lvl7pPr>
+    <a:lvl8pPr marL="3200400" algn="l" defTabSz="914400" rtl="0" eaLnBrk="1" latinLnBrk="0" hangingPunct="1">
+      <a:defRPr sz="1200" kern="1200">
+        <a:solidFill>
+          <a:schemeClr val="tx1"/>
+        </a:solidFill>
+        <a:latin typeface="+mn-lt"/>
+        <a:ea typeface="+mn-ea"/>
+        <a:cs typeface="+mn-cs"/>
+      </a:defRPr>
+    </a:lvl8pPr>
+    <a:lvl9pPr marL="3657600" algn="l" defTabSz="914400" rtl="0" eaLnBrk="1" latinLnBrk="0" hangingPunct="1">
+      <a:defRPr sz="1200" kern="1200">
+        <a:solidFill>
+          <a:schemeClr val="tx1"/>
+        </a:solidFill>
+        <a:latin typeface="+mn-lt"/>
+        <a:ea typeface="+mn-ea"/>
+        <a:cs typeface="+mn-cs"/>
+      </a:defRPr>
+    </a:lvl9pPr>
+  </p:notesStyle>
+</p:notesMaster>
 </file>
 
 <file path=ppt/slideLayouts/slideLayout1.xml><?xml version="1.0" encoding="utf-8"?>
@@ -264,7 +631,7 @@
           <a:p>
             <a:fld id="{698BA9B4-3C8A-4E29-A9A6-DF3416A26CA6}" type="datetimeFigureOut">
               <a:rPr lang="en-GB" smtClean="0"/>
-              <a:t>13/10/2026</a:t>
+              <a:t>20/10/2026</a:t>
             </a:fld>
             <a:endParaRPr lang="en-GB"/>
           </a:p>
@@ -464,7 +831,7 @@
           <a:p>
             <a:fld id="{698BA9B4-3C8A-4E29-A9A6-DF3416A26CA6}" type="datetimeFigureOut">
               <a:rPr lang="en-GB" smtClean="0"/>
-              <a:t>13/10/2026</a:t>
+              <a:t>20/10/2026</a:t>
             </a:fld>
             <a:endParaRPr lang="en-GB"/>
           </a:p>
@@ -674,7 +1041,7 @@
           <a:p>
             <a:fld id="{698BA9B4-3C8A-4E29-A9A6-DF3416A26CA6}" type="datetimeFigureOut">
               <a:rPr lang="en-GB" smtClean="0"/>
-              <a:t>13/10/2026</a:t>
+              <a:t>20/10/2026</a:t>
             </a:fld>
             <a:endParaRPr lang="en-GB"/>
           </a:p>
@@ -874,7 +1241,7 @@
           <a:p>
             <a:fld id="{698BA9B4-3C8A-4E29-A9A6-DF3416A26CA6}" type="datetimeFigureOut">
               <a:rPr lang="en-GB" smtClean="0"/>
-              <a:t>13/10/2026</a:t>
+              <a:t>20/10/2026</a:t>
             </a:fld>
             <a:endParaRPr lang="en-GB"/>
           </a:p>
@@ -1150,7 +1517,7 @@
           <a:p>
             <a:fld id="{698BA9B4-3C8A-4E29-A9A6-DF3416A26CA6}" type="datetimeFigureOut">
               <a:rPr lang="en-GB" smtClean="0"/>
-              <a:t>13/10/2026</a:t>
+              <a:t>20/10/2026</a:t>
             </a:fld>
             <a:endParaRPr lang="en-GB"/>
           </a:p>
@@ -1418,7 +1785,7 @@
           <a:p>
             <a:fld id="{698BA9B4-3C8A-4E29-A9A6-DF3416A26CA6}" type="datetimeFigureOut">
               <a:rPr lang="en-GB" smtClean="0"/>
-              <a:t>13/10/2026</a:t>
+              <a:t>20/10/2026</a:t>
             </a:fld>
             <a:endParaRPr lang="en-GB"/>
           </a:p>
@@ -1833,7 +2200,7 @@
           <a:p>
             <a:fld id="{698BA9B4-3C8A-4E29-A9A6-DF3416A26CA6}" type="datetimeFigureOut">
               <a:rPr lang="en-GB" smtClean="0"/>
-              <a:t>13/10/2026</a:t>
+              <a:t>20/10/2026</a:t>
             </a:fld>
             <a:endParaRPr lang="en-GB"/>
           </a:p>
@@ -1975,7 +2342,7 @@
           <a:p>
             <a:fld id="{698BA9B4-3C8A-4E29-A9A6-DF3416A26CA6}" type="datetimeFigureOut">
               <a:rPr lang="en-GB" smtClean="0"/>
-              <a:t>13/10/2026</a:t>
+              <a:t>20/10/2026</a:t>
             </a:fld>
             <a:endParaRPr lang="en-GB"/>
           </a:p>
@@ -2088,7 +2455,7 @@
           <a:p>
             <a:fld id="{698BA9B4-3C8A-4E29-A9A6-DF3416A26CA6}" type="datetimeFigureOut">
               <a:rPr lang="en-GB" smtClean="0"/>
-              <a:t>13/10/2026</a:t>
+              <a:t>20/10/2026</a:t>
             </a:fld>
             <a:endParaRPr lang="en-GB"/>
           </a:p>
@@ -2401,7 +2768,7 @@
           <a:p>
             <a:fld id="{698BA9B4-3C8A-4E29-A9A6-DF3416A26CA6}" type="datetimeFigureOut">
               <a:rPr lang="en-GB" smtClean="0"/>
-              <a:t>13/10/2026</a:t>
+              <a:t>20/10/2026</a:t>
             </a:fld>
             <a:endParaRPr lang="en-GB"/>
           </a:p>
@@ -2690,7 +3057,7 @@
           <a:p>
             <a:fld id="{698BA9B4-3C8A-4E29-A9A6-DF3416A26CA6}" type="datetimeFigureOut">
               <a:rPr lang="en-GB" smtClean="0"/>
-              <a:t>13/10/2026</a:t>
+              <a:t>20/10/2026</a:t>
             </a:fld>
             <a:endParaRPr lang="en-GB"/>
           </a:p>
@@ -2933,7 +3300,7 @@
           <a:p>
             <a:fld id="{698BA9B4-3C8A-4E29-A9A6-DF3416A26CA6}" type="datetimeFigureOut">
               <a:rPr lang="en-GB" smtClean="0"/>
-              <a:t>13/10/2026</a:t>
+              <a:t>20/10/2026</a:t>
             </a:fld>
             <a:endParaRPr lang="en-GB"/>
           </a:p>
@@ -3384,6 +3751,3071 @@
     <p:extLst>
       <p:ext uri="{BB962C8B-B14F-4D97-AF65-F5344CB8AC3E}">
         <p14:creationId xmlns:p14="http://schemas.microsoft.com/office/powerpoint/2010/main" val="228718810"/>
+      </p:ext>
+    </p:extLst>
+  </p:cSld>
+  <p:clrMapOvr>
+    <a:masterClrMapping/>
+  </p:clrMapOvr>
+</p:sld>
+</file>
+
+<file path=ppt/slides/slide10.xml><?xml version="1.0" encoding="utf-8"?>
+<p:sld xmlns:a="http://schemas.openxmlformats.org/drawingml/2006/main" xmlns:r="http://schemas.openxmlformats.org/officeDocument/2006/relationships" xmlns:p="http://schemas.openxmlformats.org/presentationml/2006/main">
+  <p:cSld>
+    <p:bg>
+      <p:bgPr>
+        <a:solidFill>
+          <a:schemeClr val="bg1"/>
+        </a:solidFill>
+        <a:effectLst/>
+      </p:bgPr>
+    </p:bg>
+    <p:spTree>
+      <p:nvGrpSpPr>
+        <p:cNvPr id="1" name=""/>
+        <p:cNvGrpSpPr/>
+        <p:nvPr/>
+      </p:nvGrpSpPr>
+      <p:grpSpPr>
+        <a:xfrm>
+          <a:off x="0" y="0"/>
+          <a:ext cx="0" cy="0"/>
+          <a:chOff x="0" y="0"/>
+          <a:chExt cx="0" cy="0"/>
+        </a:xfrm>
+      </p:grpSpPr>
+      <p:sp>
+        <p:nvSpPr>
+          <p:cNvPr id="10" name="Rectangle 9">
+            <a:extLst>
+              <a:ext uri="{FF2B5EF4-FFF2-40B4-BE49-F238E27FC236}">
+                <a16:creationId xmlns:a16="http://schemas.microsoft.com/office/drawing/2014/main" id="{42A4FC2C-047E-45A5-965D-8E1E3BF09BC6}"/>
+              </a:ext>
+              <a:ext uri="{C183D7F6-B498-43B3-948B-1728B52AA6E4}">
+                <adec:decorative xmlns:adec="http://schemas.microsoft.com/office/drawing/2017/decorative" val="1"/>
+              </a:ext>
+            </a:extLst>
+          </p:cNvPr>
+          <p:cNvSpPr>
+            <a:spLocks noGrp="1" noRot="1" noChangeAspect="1" noMove="1" noResize="1" noEditPoints="1" noAdjustHandles="1" noChangeArrowheads="1" noChangeShapeType="1" noTextEdit="1"/>
+          </p:cNvSpPr>
+          <p:nvPr>
+            <p:extLst>
+              <p:ext uri="{386F3935-93C4-4BCD-93E2-E3B085C9AB24}">
+                <p16:designElem xmlns:p16="http://schemas.microsoft.com/office/powerpoint/2015/main" val="1"/>
+              </p:ext>
+            </p:extLst>
+          </p:nvPr>
+        </p:nvSpPr>
+        <p:spPr bwMode="white">
+          <a:xfrm>
+            <a:off x="1524" y="0"/>
+            <a:ext cx="12188952" cy="6858000"/>
+          </a:xfrm>
+          <a:prstGeom prst="rect">
+            <a:avLst/>
+          </a:prstGeom>
+          <a:noFill/>
+          <a:ln>
+            <a:noFill/>
+          </a:ln>
+        </p:spPr>
+        <p:style>
+          <a:lnRef idx="2">
+            <a:schemeClr val="accent1">
+              <a:shade val="50000"/>
+            </a:schemeClr>
+          </a:lnRef>
+          <a:fillRef idx="1">
+            <a:schemeClr val="accent1"/>
+          </a:fillRef>
+          <a:effectRef idx="0">
+            <a:schemeClr val="accent1"/>
+          </a:effectRef>
+          <a:fontRef idx="minor">
+            <a:schemeClr val="lt1"/>
+          </a:fontRef>
+        </p:style>
+        <p:txBody>
+          <a:bodyPr rtlCol="0" anchor="ctr"/>
+          <a:lstStyle>
+            <a:defPPr>
+              <a:defRPr lang="en-US"/>
+            </a:defPPr>
+            <a:lvl1pPr marL="0" algn="l" defTabSz="914400" rtl="0" eaLnBrk="1" latinLnBrk="0" hangingPunct="1">
+              <a:defRPr sz="1800" kern="1200">
+                <a:solidFill>
+                  <a:schemeClr val="lt1"/>
+                </a:solidFill>
+                <a:latin typeface="+mn-lt"/>
+                <a:ea typeface="+mn-ea"/>
+                <a:cs typeface="+mn-cs"/>
+              </a:defRPr>
+            </a:lvl1pPr>
+            <a:lvl2pPr marL="457200" algn="l" defTabSz="914400" rtl="0" eaLnBrk="1" latinLnBrk="0" hangingPunct="1">
+              <a:defRPr sz="1800" kern="1200">
+                <a:solidFill>
+                  <a:schemeClr val="lt1"/>
+                </a:solidFill>
+                <a:latin typeface="+mn-lt"/>
+                <a:ea typeface="+mn-ea"/>
+                <a:cs typeface="+mn-cs"/>
+              </a:defRPr>
+            </a:lvl2pPr>
+            <a:lvl3pPr marL="914400" algn="l" defTabSz="914400" rtl="0" eaLnBrk="1" latinLnBrk="0" hangingPunct="1">
+              <a:defRPr sz="1800" kern="1200">
+                <a:solidFill>
+                  <a:schemeClr val="lt1"/>
+                </a:solidFill>
+                <a:latin typeface="+mn-lt"/>
+                <a:ea typeface="+mn-ea"/>
+                <a:cs typeface="+mn-cs"/>
+              </a:defRPr>
+            </a:lvl3pPr>
+            <a:lvl4pPr marL="1371600" algn="l" defTabSz="914400" rtl="0" eaLnBrk="1" latinLnBrk="0" hangingPunct="1">
+              <a:defRPr sz="1800" kern="1200">
+                <a:solidFill>
+                  <a:schemeClr val="lt1"/>
+                </a:solidFill>
+                <a:latin typeface="+mn-lt"/>
+                <a:ea typeface="+mn-ea"/>
+                <a:cs typeface="+mn-cs"/>
+              </a:defRPr>
+            </a:lvl4pPr>
+            <a:lvl5pPr marL="1828800" algn="l" defTabSz="914400" rtl="0" eaLnBrk="1" latinLnBrk="0" hangingPunct="1">
+              <a:defRPr sz="1800" kern="1200">
+                <a:solidFill>
+                  <a:schemeClr val="lt1"/>
+                </a:solidFill>
+                <a:latin typeface="+mn-lt"/>
+                <a:ea typeface="+mn-ea"/>
+                <a:cs typeface="+mn-cs"/>
+              </a:defRPr>
+            </a:lvl5pPr>
+            <a:lvl6pPr marL="2286000" algn="l" defTabSz="914400" rtl="0" eaLnBrk="1" latinLnBrk="0" hangingPunct="1">
+              <a:defRPr sz="1800" kern="1200">
+                <a:solidFill>
+                  <a:schemeClr val="lt1"/>
+                </a:solidFill>
+                <a:latin typeface="+mn-lt"/>
+                <a:ea typeface="+mn-ea"/>
+                <a:cs typeface="+mn-cs"/>
+              </a:defRPr>
+            </a:lvl6pPr>
+            <a:lvl7pPr marL="2743200" algn="l" defTabSz="914400" rtl="0" eaLnBrk="1" latinLnBrk="0" hangingPunct="1">
+              <a:defRPr sz="1800" kern="1200">
+                <a:solidFill>
+                  <a:schemeClr val="lt1"/>
+                </a:solidFill>
+                <a:latin typeface="+mn-lt"/>
+                <a:ea typeface="+mn-ea"/>
+                <a:cs typeface="+mn-cs"/>
+              </a:defRPr>
+            </a:lvl7pPr>
+            <a:lvl8pPr marL="3200400" algn="l" defTabSz="914400" rtl="0" eaLnBrk="1" latinLnBrk="0" hangingPunct="1">
+              <a:defRPr sz="1800" kern="1200">
+                <a:solidFill>
+                  <a:schemeClr val="lt1"/>
+                </a:solidFill>
+                <a:latin typeface="+mn-lt"/>
+                <a:ea typeface="+mn-ea"/>
+                <a:cs typeface="+mn-cs"/>
+              </a:defRPr>
+            </a:lvl8pPr>
+            <a:lvl9pPr marL="3657600" algn="l" defTabSz="914400" rtl="0" eaLnBrk="1" latinLnBrk="0" hangingPunct="1">
+              <a:defRPr sz="1800" kern="1200">
+                <a:solidFill>
+                  <a:schemeClr val="lt1"/>
+                </a:solidFill>
+                <a:latin typeface="+mn-lt"/>
+                <a:ea typeface="+mn-ea"/>
+                <a:cs typeface="+mn-cs"/>
+              </a:defRPr>
+            </a:lvl9pPr>
+          </a:lstStyle>
+          <a:p>
+            <a:pPr algn="ctr"/>
+            <a:endParaRPr lang="en-US"/>
+          </a:p>
+        </p:txBody>
+      </p:sp>
+      <p:pic>
+        <p:nvPicPr>
+          <p:cNvPr id="5" name="Picture 4">
+            <a:extLst>
+              <a:ext uri="{FF2B5EF4-FFF2-40B4-BE49-F238E27FC236}">
+                <a16:creationId xmlns:a16="http://schemas.microsoft.com/office/drawing/2014/main" id="{35AD412D-FD05-E261-CC3B-33B219BB8DF8}"/>
+              </a:ext>
+            </a:extLst>
+          </p:cNvPr>
+          <p:cNvPicPr>
+            <a:picLocks noChangeAspect="1"/>
+          </p:cNvPicPr>
+          <p:nvPr/>
+        </p:nvPicPr>
+        <p:blipFill>
+          <a:blip r:embed="rId2"/>
+          <a:srcRect b="3035"/>
+          <a:stretch>
+            <a:fillRect/>
+          </a:stretch>
+        </p:blipFill>
+        <p:spPr>
+          <a:xfrm>
+            <a:off x="20" y="1282"/>
+            <a:ext cx="12191980" cy="6856718"/>
+          </a:xfrm>
+          <a:prstGeom prst="rect">
+            <a:avLst/>
+          </a:prstGeom>
+        </p:spPr>
+      </p:pic>
+      <p:sp>
+        <p:nvSpPr>
+          <p:cNvPr id="6" name="TextBox 5">
+            <a:extLst>
+              <a:ext uri="{FF2B5EF4-FFF2-40B4-BE49-F238E27FC236}">
+                <a16:creationId xmlns:a16="http://schemas.microsoft.com/office/drawing/2014/main" id="{90A4C05B-EB49-083B-93D7-83C4FA8ECECE}"/>
+              </a:ext>
+            </a:extLst>
+          </p:cNvPr>
+          <p:cNvSpPr txBox="1"/>
+          <p:nvPr/>
+        </p:nvSpPr>
+        <p:spPr>
+          <a:xfrm>
+            <a:off x="6421741" y="265246"/>
+            <a:ext cx="1056700" cy="369332"/>
+          </a:xfrm>
+          <a:prstGeom prst="rect">
+            <a:avLst/>
+          </a:prstGeom>
+          <a:noFill/>
+        </p:spPr>
+        <p:txBody>
+          <a:bodyPr wrap="none" rtlCol="0">
+            <a:spAutoFit/>
+          </a:bodyPr>
+          <a:lstStyle/>
+          <a:p>
+            <a:r>
+              <a:rPr lang="vi-VN" dirty="0">
+                <a:solidFill>
+                  <a:schemeClr val="bg1"/>
+                </a:solidFill>
+              </a:rPr>
+              <a:t>Danh bạ</a:t>
+            </a:r>
+            <a:endParaRPr lang="en-GB" dirty="0">
+              <a:solidFill>
+                <a:schemeClr val="bg1"/>
+              </a:solidFill>
+            </a:endParaRPr>
+          </a:p>
+        </p:txBody>
+      </p:sp>
+    </p:spTree>
+    <p:extLst>
+      <p:ext uri="{BB962C8B-B14F-4D97-AF65-F5344CB8AC3E}">
+        <p14:creationId xmlns:p14="http://schemas.microsoft.com/office/powerpoint/2010/main" val="169407802"/>
+      </p:ext>
+    </p:extLst>
+  </p:cSld>
+  <p:clrMapOvr>
+    <a:masterClrMapping/>
+  </p:clrMapOvr>
+</p:sld>
+</file>
+
+<file path=ppt/slides/slide11.xml><?xml version="1.0" encoding="utf-8"?>
+<p:sld xmlns:a="http://schemas.openxmlformats.org/drawingml/2006/main" xmlns:r="http://schemas.openxmlformats.org/officeDocument/2006/relationships" xmlns:p="http://schemas.openxmlformats.org/presentationml/2006/main">
+  <p:cSld>
+    <p:spTree>
+      <p:nvGrpSpPr>
+        <p:cNvPr id="1" name="">
+          <a:extLst>
+            <a:ext uri="{FF2B5EF4-FFF2-40B4-BE49-F238E27FC236}">
+              <a16:creationId xmlns:a16="http://schemas.microsoft.com/office/drawing/2014/main" id="{55AA586F-32E0-ED7F-4A10-9E32948D8480}"/>
+            </a:ext>
+          </a:extLst>
+        </p:cNvPr>
+        <p:cNvGrpSpPr/>
+        <p:nvPr/>
+      </p:nvGrpSpPr>
+      <p:grpSpPr>
+        <a:xfrm>
+          <a:off x="0" y="0"/>
+          <a:ext cx="0" cy="0"/>
+          <a:chOff x="0" y="0"/>
+          <a:chExt cx="0" cy="0"/>
+        </a:xfrm>
+      </p:grpSpPr>
+      <p:sp>
+        <p:nvSpPr>
+          <p:cNvPr id="2" name="Title 1">
+            <a:extLst>
+              <a:ext uri="{FF2B5EF4-FFF2-40B4-BE49-F238E27FC236}">
+                <a16:creationId xmlns:a16="http://schemas.microsoft.com/office/drawing/2014/main" id="{55A8616E-B942-414A-2C78-FF6BA185C60F}"/>
+              </a:ext>
+            </a:extLst>
+          </p:cNvPr>
+          <p:cNvSpPr>
+            <a:spLocks noGrp="1"/>
+          </p:cNvSpPr>
+          <p:nvPr>
+            <p:ph type="title"/>
+          </p:nvPr>
+        </p:nvSpPr>
+        <p:spPr>
+          <a:xfrm>
+            <a:off x="180611" y="148742"/>
+            <a:ext cx="11830777" cy="688878"/>
+          </a:xfrm>
+        </p:spPr>
+        <p:txBody>
+          <a:bodyPr>
+            <a:normAutofit fontScale="90000"/>
+          </a:bodyPr>
+          <a:lstStyle/>
+          <a:p>
+            <a:r>
+              <a:rPr lang="vi-VN" sz="2800" dirty="0"/>
+              <a:t>Sơ đồ khối nwdaf gốc: </a:t>
+            </a:r>
+            <a:r>
+              <a:rPr lang="en-GB" sz="2800" dirty="0"/>
+              <a:t>An Implementation Study of Network Data Analytic Function in 5G</a:t>
+            </a:r>
+            <a:r>
+              <a:rPr lang="vi-VN" sz="2800" dirty="0"/>
+              <a:t> </a:t>
+            </a:r>
+            <a:endParaRPr lang="en-GB" sz="2800" dirty="0"/>
+          </a:p>
+        </p:txBody>
+      </p:sp>
+      <p:pic>
+        <p:nvPicPr>
+          <p:cNvPr id="5" name="Picture 4">
+            <a:extLst>
+              <a:ext uri="{FF2B5EF4-FFF2-40B4-BE49-F238E27FC236}">
+                <a16:creationId xmlns:a16="http://schemas.microsoft.com/office/drawing/2014/main" id="{05FA0C44-2E90-BA76-E8BF-BA5D7606126A}"/>
+              </a:ext>
+            </a:extLst>
+          </p:cNvPr>
+          <p:cNvPicPr>
+            <a:picLocks noChangeAspect="1"/>
+          </p:cNvPicPr>
+          <p:nvPr/>
+        </p:nvPicPr>
+        <p:blipFill>
+          <a:blip r:embed="rId2"/>
+          <a:stretch>
+            <a:fillRect/>
+          </a:stretch>
+        </p:blipFill>
+        <p:spPr>
+          <a:xfrm>
+            <a:off x="-285457" y="779766"/>
+            <a:ext cx="12871402" cy="4985590"/>
+          </a:xfrm>
+          <a:prstGeom prst="rect">
+            <a:avLst/>
+          </a:prstGeom>
+        </p:spPr>
+      </p:pic>
+    </p:spTree>
+    <p:extLst>
+      <p:ext uri="{BB962C8B-B14F-4D97-AF65-F5344CB8AC3E}">
+        <p14:creationId xmlns:p14="http://schemas.microsoft.com/office/powerpoint/2010/main" val="3633899096"/>
+      </p:ext>
+    </p:extLst>
+  </p:cSld>
+  <p:clrMapOvr>
+    <a:masterClrMapping/>
+  </p:clrMapOvr>
+</p:sld>
+</file>
+
+<file path=ppt/slides/slide12.xml><?xml version="1.0" encoding="utf-8"?>
+<p:sld xmlns:a="http://schemas.openxmlformats.org/drawingml/2006/main" xmlns:r="http://schemas.openxmlformats.org/officeDocument/2006/relationships" xmlns:p="http://schemas.openxmlformats.org/presentationml/2006/main">
+  <p:cSld>
+    <p:spTree>
+      <p:nvGrpSpPr>
+        <p:cNvPr id="1" name="">
+          <a:extLst>
+            <a:ext uri="{FF2B5EF4-FFF2-40B4-BE49-F238E27FC236}">
+              <a16:creationId xmlns:a16="http://schemas.microsoft.com/office/drawing/2014/main" id="{D2131F88-569B-8CB5-8905-53BED89B1C77}"/>
+            </a:ext>
+          </a:extLst>
+        </p:cNvPr>
+        <p:cNvGrpSpPr/>
+        <p:nvPr/>
+      </p:nvGrpSpPr>
+      <p:grpSpPr>
+        <a:xfrm>
+          <a:off x="0" y="0"/>
+          <a:ext cx="0" cy="0"/>
+          <a:chOff x="0" y="0"/>
+          <a:chExt cx="0" cy="0"/>
+        </a:xfrm>
+      </p:grpSpPr>
+      <p:pic>
+        <p:nvPicPr>
+          <p:cNvPr id="11" name="Picture 10">
+            <a:extLst>
+              <a:ext uri="{FF2B5EF4-FFF2-40B4-BE49-F238E27FC236}">
+                <a16:creationId xmlns:a16="http://schemas.microsoft.com/office/drawing/2014/main" id="{C9E02328-FC7B-7120-078F-8DFB3E9FF042}"/>
+              </a:ext>
+            </a:extLst>
+          </p:cNvPr>
+          <p:cNvPicPr>
+            <a:picLocks noChangeAspect="1"/>
+          </p:cNvPicPr>
+          <p:nvPr/>
+        </p:nvPicPr>
+        <p:blipFill>
+          <a:blip r:embed="rId2"/>
+          <a:stretch>
+            <a:fillRect/>
+          </a:stretch>
+        </p:blipFill>
+        <p:spPr>
+          <a:xfrm>
+            <a:off x="-383631" y="364210"/>
+            <a:ext cx="12575631" cy="5109150"/>
+          </a:xfrm>
+          <a:prstGeom prst="rect">
+            <a:avLst/>
+          </a:prstGeom>
+        </p:spPr>
+      </p:pic>
+    </p:spTree>
+    <p:extLst>
+      <p:ext uri="{BB962C8B-B14F-4D97-AF65-F5344CB8AC3E}">
+        <p14:creationId xmlns:p14="http://schemas.microsoft.com/office/powerpoint/2010/main" val="1107215081"/>
+      </p:ext>
+    </p:extLst>
+  </p:cSld>
+  <p:clrMapOvr>
+    <a:masterClrMapping/>
+  </p:clrMapOvr>
+</p:sld>
+</file>
+
+<file path=ppt/slides/slide13.xml><?xml version="1.0" encoding="utf-8"?>
+<p:sld xmlns:a="http://schemas.openxmlformats.org/drawingml/2006/main" xmlns:r="http://schemas.openxmlformats.org/officeDocument/2006/relationships" xmlns:p="http://schemas.openxmlformats.org/presentationml/2006/main">
+  <p:cSld>
+    <p:spTree>
+      <p:nvGrpSpPr>
+        <p:cNvPr id="1" name="">
+          <a:extLst>
+            <a:ext uri="{FF2B5EF4-FFF2-40B4-BE49-F238E27FC236}">
+              <a16:creationId xmlns:a16="http://schemas.microsoft.com/office/drawing/2014/main" id="{94FF939E-A308-F5E6-A969-85F007909D16}"/>
+            </a:ext>
+          </a:extLst>
+        </p:cNvPr>
+        <p:cNvGrpSpPr/>
+        <p:nvPr/>
+      </p:nvGrpSpPr>
+      <p:grpSpPr>
+        <a:xfrm>
+          <a:off x="0" y="0"/>
+          <a:ext cx="0" cy="0"/>
+          <a:chOff x="0" y="0"/>
+          <a:chExt cx="0" cy="0"/>
+        </a:xfrm>
+      </p:grpSpPr>
+      <p:pic>
+        <p:nvPicPr>
+          <p:cNvPr id="5" name="Picture 4">
+            <a:extLst>
+              <a:ext uri="{FF2B5EF4-FFF2-40B4-BE49-F238E27FC236}">
+                <a16:creationId xmlns:a16="http://schemas.microsoft.com/office/drawing/2014/main" id="{464DF801-42B8-9730-6219-8B99E8C0CC22}"/>
+              </a:ext>
+            </a:extLst>
+          </p:cNvPr>
+          <p:cNvPicPr>
+            <a:picLocks noChangeAspect="1"/>
+          </p:cNvPicPr>
+          <p:nvPr/>
+        </p:nvPicPr>
+        <p:blipFill>
+          <a:blip r:embed="rId2"/>
+          <a:stretch>
+            <a:fillRect/>
+          </a:stretch>
+        </p:blipFill>
+        <p:spPr>
+          <a:xfrm>
+            <a:off x="-74908" y="510755"/>
+            <a:ext cx="12266908" cy="4245017"/>
+          </a:xfrm>
+          <a:prstGeom prst="rect">
+            <a:avLst/>
+          </a:prstGeom>
+        </p:spPr>
+      </p:pic>
+      <p:sp>
+        <p:nvSpPr>
+          <p:cNvPr id="7" name="TextBox 6">
+            <a:extLst>
+              <a:ext uri="{FF2B5EF4-FFF2-40B4-BE49-F238E27FC236}">
+                <a16:creationId xmlns:a16="http://schemas.microsoft.com/office/drawing/2014/main" id="{4E66590C-D476-3644-4427-11A8718CEA2B}"/>
+              </a:ext>
+            </a:extLst>
+          </p:cNvPr>
+          <p:cNvSpPr txBox="1"/>
+          <p:nvPr/>
+        </p:nvSpPr>
+        <p:spPr>
+          <a:xfrm>
+            <a:off x="4163419" y="2435"/>
+            <a:ext cx="3865161" cy="369332"/>
+          </a:xfrm>
+          <a:prstGeom prst="rect">
+            <a:avLst/>
+          </a:prstGeom>
+          <a:noFill/>
+        </p:spPr>
+        <p:txBody>
+          <a:bodyPr wrap="none" rtlCol="0">
+            <a:spAutoFit/>
+          </a:bodyPr>
+          <a:lstStyle/>
+          <a:p>
+            <a:r>
+              <a:rPr lang="vi-VN" dirty="0"/>
+              <a:t>Đầu vào – ra của UE mobility model</a:t>
+            </a:r>
+            <a:endParaRPr lang="en-GB" dirty="0"/>
+          </a:p>
+        </p:txBody>
+      </p:sp>
+      <p:sp>
+        <p:nvSpPr>
+          <p:cNvPr id="8" name="TextBox 7">
+            <a:extLst>
+              <a:ext uri="{FF2B5EF4-FFF2-40B4-BE49-F238E27FC236}">
+                <a16:creationId xmlns:a16="http://schemas.microsoft.com/office/drawing/2014/main" id="{13F84A97-BEE1-2D6D-8745-46F4CA892260}"/>
+              </a:ext>
+            </a:extLst>
+          </p:cNvPr>
+          <p:cNvSpPr txBox="1"/>
+          <p:nvPr/>
+        </p:nvSpPr>
+        <p:spPr>
+          <a:xfrm>
+            <a:off x="2331372" y="2743200"/>
+            <a:ext cx="1887889" cy="1477328"/>
+          </a:xfrm>
+          <a:prstGeom prst="rect">
+            <a:avLst/>
+          </a:prstGeom>
+          <a:noFill/>
+        </p:spPr>
+        <p:txBody>
+          <a:bodyPr wrap="square" rtlCol="0">
+            <a:spAutoFit/>
+          </a:bodyPr>
+          <a:lstStyle/>
+          <a:p>
+            <a:r>
+              <a:rPr lang="vi-VN" dirty="0">
+                <a:solidFill>
+                  <a:schemeClr val="bg1"/>
+                </a:solidFill>
+              </a:rPr>
+              <a:t>Mô phỏng theo nhịp điệu con người (ko phải xe/uav) trên nền map 2d</a:t>
+            </a:r>
+            <a:endParaRPr lang="en-GB" dirty="0">
+              <a:solidFill>
+                <a:schemeClr val="bg1"/>
+              </a:solidFill>
+            </a:endParaRPr>
+          </a:p>
+        </p:txBody>
+      </p:sp>
+      <p:sp>
+        <p:nvSpPr>
+          <p:cNvPr id="9" name="TextBox 8">
+            <a:extLst>
+              <a:ext uri="{FF2B5EF4-FFF2-40B4-BE49-F238E27FC236}">
+                <a16:creationId xmlns:a16="http://schemas.microsoft.com/office/drawing/2014/main" id="{3F8BF4D8-1C45-ABD4-13E8-10AB92E1FB4D}"/>
+              </a:ext>
+            </a:extLst>
+          </p:cNvPr>
+          <p:cNvSpPr txBox="1"/>
+          <p:nvPr/>
+        </p:nvSpPr>
+        <p:spPr>
+          <a:xfrm>
+            <a:off x="10007212" y="2880596"/>
+            <a:ext cx="1887890" cy="1477328"/>
+          </a:xfrm>
+          <a:prstGeom prst="rect">
+            <a:avLst/>
+          </a:prstGeom>
+          <a:noFill/>
+        </p:spPr>
+        <p:txBody>
+          <a:bodyPr wrap="square" rtlCol="0">
+            <a:spAutoFit/>
+          </a:bodyPr>
+          <a:lstStyle/>
+          <a:p>
+            <a:r>
+              <a:rPr lang="vi-VN" dirty="0">
+                <a:solidFill>
+                  <a:schemeClr val="bg1"/>
+                </a:solidFill>
+              </a:rPr>
+              <a:t>Dữ liệu đầu ra không có SINR / RSRP ... do free5gc ko hỗ trợ </a:t>
+            </a:r>
+            <a:endParaRPr lang="en-GB" dirty="0">
+              <a:solidFill>
+                <a:schemeClr val="bg1"/>
+              </a:solidFill>
+            </a:endParaRPr>
+          </a:p>
+        </p:txBody>
+      </p:sp>
+      <p:sp>
+        <p:nvSpPr>
+          <p:cNvPr id="11" name="TextBox 10">
+            <a:extLst>
+              <a:ext uri="{FF2B5EF4-FFF2-40B4-BE49-F238E27FC236}">
+                <a16:creationId xmlns:a16="http://schemas.microsoft.com/office/drawing/2014/main" id="{E92CD486-8BA4-94FE-D987-34AE5224EB98}"/>
+              </a:ext>
+            </a:extLst>
+          </p:cNvPr>
+          <p:cNvSpPr txBox="1"/>
+          <p:nvPr/>
+        </p:nvSpPr>
+        <p:spPr>
+          <a:xfrm>
+            <a:off x="6976662" y="4978521"/>
+            <a:ext cx="4994299" cy="1477328"/>
+          </a:xfrm>
+          <a:prstGeom prst="rect">
+            <a:avLst/>
+          </a:prstGeom>
+          <a:noFill/>
+        </p:spPr>
+        <p:txBody>
+          <a:bodyPr wrap="square">
+            <a:spAutoFit/>
+          </a:bodyPr>
+          <a:lstStyle/>
+          <a:p>
+            <a:r>
+              <a:rPr lang="en-GB" dirty="0" err="1"/>
+              <a:t>Bài</a:t>
+            </a:r>
+            <a:r>
+              <a:rPr lang="en-GB" dirty="0"/>
+              <a:t> </a:t>
+            </a:r>
+            <a:r>
+              <a:rPr lang="en-GB" dirty="0" err="1"/>
+              <a:t>báo</a:t>
+            </a:r>
+            <a:r>
+              <a:rPr lang="en-GB" dirty="0"/>
+              <a:t> </a:t>
+            </a:r>
+            <a:r>
+              <a:rPr lang="en-GB" dirty="0" err="1"/>
+              <a:t>xem</a:t>
+            </a:r>
+            <a:r>
+              <a:rPr lang="en-GB" dirty="0"/>
+              <a:t> </a:t>
+            </a:r>
+            <a:r>
+              <a:rPr lang="en-GB" dirty="0" err="1"/>
+              <a:t>việc</a:t>
+            </a:r>
+            <a:r>
+              <a:rPr lang="en-GB" dirty="0"/>
+              <a:t> </a:t>
+            </a:r>
+            <a:r>
+              <a:rPr lang="en-GB" dirty="0" err="1"/>
+              <a:t>chuyển</a:t>
+            </a:r>
+            <a:r>
+              <a:rPr lang="en-GB" dirty="0"/>
+              <a:t> </a:t>
+            </a:r>
+            <a:r>
+              <a:rPr lang="en-GB" dirty="0" err="1"/>
+              <a:t>giao</a:t>
+            </a:r>
+            <a:r>
+              <a:rPr lang="en-GB" dirty="0"/>
+              <a:t> </a:t>
+            </a:r>
+            <a:r>
+              <a:rPr lang="en-GB" dirty="0" err="1"/>
+              <a:t>là</a:t>
+            </a:r>
+            <a:r>
+              <a:rPr lang="en-GB" dirty="0"/>
+              <a:t> </a:t>
+            </a:r>
+            <a:r>
+              <a:rPr lang="en-GB" b="1" dirty="0" err="1"/>
+              <a:t>dự</a:t>
+            </a:r>
+            <a:r>
+              <a:rPr lang="en-GB" b="1" dirty="0"/>
+              <a:t> </a:t>
+            </a:r>
+            <a:r>
+              <a:rPr lang="en-GB" b="1" dirty="0" err="1"/>
+              <a:t>đoán</a:t>
+            </a:r>
+            <a:r>
+              <a:rPr lang="en-GB" b="1" dirty="0"/>
+              <a:t> Cell ID </a:t>
+            </a:r>
+            <a:r>
+              <a:rPr lang="en-GB" b="1" dirty="0" err="1"/>
+              <a:t>tiếp</a:t>
+            </a:r>
+            <a:r>
+              <a:rPr lang="en-GB" b="1" dirty="0"/>
+              <a:t> </a:t>
+            </a:r>
+            <a:r>
+              <a:rPr lang="en-GB" b="1" dirty="0" err="1"/>
+              <a:t>theo</a:t>
+            </a:r>
+            <a:r>
+              <a:rPr lang="en-GB" b="1" dirty="0"/>
+              <a:t> (next </a:t>
+            </a:r>
+            <a:r>
+              <a:rPr lang="en-GB" b="1" dirty="0" err="1"/>
+              <a:t>NrCellId</a:t>
+            </a:r>
+            <a:r>
+              <a:rPr lang="en-GB" b="1" dirty="0"/>
+              <a:t>)</a:t>
+            </a:r>
+            <a:r>
+              <a:rPr lang="en-GB" dirty="0"/>
+              <a:t> </a:t>
+            </a:r>
+            <a:r>
+              <a:rPr lang="en-GB" dirty="0" err="1"/>
+              <a:t>dựa</a:t>
+            </a:r>
+            <a:r>
+              <a:rPr lang="en-GB" dirty="0"/>
+              <a:t> </a:t>
+            </a:r>
+            <a:r>
+              <a:rPr lang="en-GB" dirty="0" err="1"/>
+              <a:t>trên</a:t>
+            </a:r>
+            <a:r>
+              <a:rPr lang="en-GB" dirty="0"/>
+              <a:t> </a:t>
+            </a:r>
+            <a:r>
+              <a:rPr lang="en-GB" dirty="0" err="1"/>
+              <a:t>quy</a:t>
+            </a:r>
+            <a:r>
+              <a:rPr lang="en-GB" dirty="0"/>
+              <a:t> </a:t>
+            </a:r>
+            <a:r>
+              <a:rPr lang="en-GB" dirty="0" err="1"/>
+              <a:t>luật</a:t>
+            </a:r>
+            <a:r>
+              <a:rPr lang="en-GB" dirty="0"/>
+              <a:t> di </a:t>
+            </a:r>
+            <a:r>
+              <a:rPr lang="en-GB" dirty="0" err="1"/>
+              <a:t>chuyển</a:t>
+            </a:r>
+            <a:r>
+              <a:rPr lang="en-GB" dirty="0"/>
+              <a:t> </a:t>
+            </a:r>
+            <a:r>
+              <a:rPr lang="en-GB" dirty="0" err="1"/>
+              <a:t>trong</a:t>
+            </a:r>
+            <a:r>
+              <a:rPr lang="en-GB" dirty="0"/>
+              <a:t> </a:t>
+            </a:r>
+            <a:r>
+              <a:rPr lang="en-GB" dirty="0" err="1"/>
+              <a:t>quá</a:t>
+            </a:r>
+            <a:r>
+              <a:rPr lang="en-GB" dirty="0"/>
+              <a:t> </a:t>
+            </a:r>
+            <a:r>
+              <a:rPr lang="en-GB" dirty="0" err="1"/>
+              <a:t>khứ</a:t>
+            </a:r>
+            <a:r>
+              <a:rPr lang="en-GB" dirty="0"/>
+              <a:t> </a:t>
+            </a:r>
+            <a:r>
+              <a:rPr lang="en-GB" dirty="0" err="1"/>
+              <a:t>của</a:t>
+            </a:r>
+            <a:r>
+              <a:rPr lang="en-GB" dirty="0"/>
+              <a:t> </a:t>
+            </a:r>
+            <a:r>
+              <a:rPr lang="en-GB" dirty="0" err="1"/>
+              <a:t>thiết</a:t>
+            </a:r>
+            <a:r>
+              <a:rPr lang="en-GB" dirty="0"/>
+              <a:t> </a:t>
+            </a:r>
+            <a:r>
+              <a:rPr lang="en-GB" dirty="0" err="1"/>
+              <a:t>bị</a:t>
+            </a:r>
+            <a:r>
+              <a:rPr lang="en-GB" dirty="0"/>
+              <a:t>, </a:t>
+            </a:r>
+            <a:r>
+              <a:rPr lang="en-GB" dirty="0" err="1"/>
+              <a:t>chứ</a:t>
+            </a:r>
+            <a:r>
+              <a:rPr lang="en-GB" dirty="0"/>
+              <a:t> </a:t>
+            </a:r>
+            <a:r>
+              <a:rPr lang="en-GB" dirty="0" err="1"/>
+              <a:t>không</a:t>
+            </a:r>
+            <a:r>
+              <a:rPr lang="en-GB" dirty="0"/>
+              <a:t> </a:t>
+            </a:r>
+            <a:r>
+              <a:rPr lang="en-GB" dirty="0" err="1"/>
+              <a:t>tính</a:t>
+            </a:r>
+            <a:r>
+              <a:rPr lang="en-GB" dirty="0"/>
+              <a:t> </a:t>
+            </a:r>
+            <a:r>
+              <a:rPr lang="en-GB" dirty="0" err="1"/>
+              <a:t>toán</a:t>
+            </a:r>
+            <a:r>
+              <a:rPr lang="en-GB" dirty="0"/>
+              <a:t> </a:t>
+            </a:r>
+            <a:r>
+              <a:rPr lang="en-GB" dirty="0" err="1"/>
+              <a:t>tọa</a:t>
+            </a:r>
+            <a:r>
+              <a:rPr lang="en-GB" dirty="0"/>
+              <a:t> </a:t>
+            </a:r>
+            <a:r>
+              <a:rPr lang="en-GB" dirty="0" err="1"/>
+              <a:t>độ</a:t>
+            </a:r>
+            <a:r>
+              <a:rPr lang="en-GB" dirty="0"/>
+              <a:t> hay </a:t>
+            </a:r>
+            <a:r>
+              <a:rPr lang="en-GB" dirty="0" err="1"/>
+              <a:t>khoảng</a:t>
+            </a:r>
+            <a:r>
+              <a:rPr lang="en-GB" dirty="0"/>
+              <a:t> </a:t>
+            </a:r>
+            <a:r>
+              <a:rPr lang="en-GB" dirty="0" err="1"/>
+              <a:t>cách</a:t>
+            </a:r>
+            <a:r>
+              <a:rPr lang="en-GB" dirty="0"/>
+              <a:t> </a:t>
+            </a:r>
+            <a:r>
+              <a:rPr lang="en-GB" dirty="0" err="1"/>
+              <a:t>hình</a:t>
+            </a:r>
+            <a:r>
+              <a:rPr lang="en-GB" dirty="0"/>
+              <a:t> </a:t>
+            </a:r>
+            <a:r>
+              <a:rPr lang="en-GB" dirty="0" err="1"/>
+              <a:t>học</a:t>
+            </a:r>
+            <a:r>
+              <a:rPr lang="en-GB" dirty="0"/>
+              <a:t> </a:t>
+            </a:r>
+            <a:r>
+              <a:rPr lang="en-GB" dirty="0" err="1"/>
+              <a:t>để</a:t>
+            </a:r>
+            <a:r>
+              <a:rPr lang="en-GB" dirty="0"/>
+              <a:t> </a:t>
+            </a:r>
+            <a:r>
+              <a:rPr lang="en-GB" dirty="0" err="1"/>
+              <a:t>tìm</a:t>
+            </a:r>
+            <a:r>
+              <a:rPr lang="en-GB" dirty="0"/>
+              <a:t> </a:t>
+            </a:r>
+            <a:r>
+              <a:rPr lang="en-GB" dirty="0" err="1"/>
+              <a:t>gNodeB</a:t>
+            </a:r>
+            <a:r>
+              <a:rPr lang="en-GB" dirty="0"/>
+              <a:t> </a:t>
+            </a:r>
+            <a:r>
+              <a:rPr lang="en-GB" dirty="0" err="1"/>
+              <a:t>gần</a:t>
+            </a:r>
+            <a:r>
+              <a:rPr lang="en-GB" dirty="0"/>
+              <a:t> </a:t>
+            </a:r>
+            <a:r>
+              <a:rPr lang="en-GB" dirty="0" err="1"/>
+              <a:t>nhất</a:t>
+            </a:r>
+            <a:endParaRPr lang="en-GB" dirty="0"/>
+          </a:p>
+        </p:txBody>
+      </p:sp>
+      <p:sp>
+        <p:nvSpPr>
+          <p:cNvPr id="13" name="TextBox 12">
+            <a:extLst>
+              <a:ext uri="{FF2B5EF4-FFF2-40B4-BE49-F238E27FC236}">
+                <a16:creationId xmlns:a16="http://schemas.microsoft.com/office/drawing/2014/main" id="{5ADC4289-4C78-5DD9-3912-4FA5DE698EAF}"/>
+              </a:ext>
+            </a:extLst>
+          </p:cNvPr>
+          <p:cNvSpPr txBox="1"/>
+          <p:nvPr/>
+        </p:nvSpPr>
+        <p:spPr>
+          <a:xfrm>
+            <a:off x="270675" y="5045893"/>
+            <a:ext cx="2507425" cy="1200329"/>
+          </a:xfrm>
+          <a:prstGeom prst="rect">
+            <a:avLst/>
+          </a:prstGeom>
+          <a:noFill/>
+        </p:spPr>
+        <p:txBody>
+          <a:bodyPr wrap="square">
+            <a:spAutoFit/>
+          </a:bodyPr>
+          <a:lstStyle/>
+          <a:p>
+            <a:r>
+              <a:rPr lang="en-GB" dirty="0" err="1">
+                <a:effectLst/>
+                <a:latin typeface="+mn-lt"/>
+              </a:rPr>
+              <a:t>Tác</a:t>
+            </a:r>
+            <a:r>
+              <a:rPr lang="en-GB" dirty="0">
+                <a:effectLst/>
+                <a:latin typeface="+mn-lt"/>
+              </a:rPr>
+              <a:t> </a:t>
+            </a:r>
+            <a:r>
+              <a:rPr lang="en-GB" dirty="0" err="1">
+                <a:effectLst/>
+                <a:latin typeface="+mn-lt"/>
+              </a:rPr>
+              <a:t>giả</a:t>
+            </a:r>
+            <a:r>
+              <a:rPr lang="en-GB" dirty="0">
+                <a:effectLst/>
+                <a:latin typeface="+mn-lt"/>
+              </a:rPr>
+              <a:t> </a:t>
+            </a:r>
+            <a:r>
+              <a:rPr lang="en-GB" dirty="0" err="1">
+                <a:effectLst/>
+                <a:latin typeface="+mn-lt"/>
+              </a:rPr>
+              <a:t>dùng</a:t>
+            </a:r>
+            <a:r>
+              <a:rPr lang="en-GB" dirty="0">
+                <a:effectLst/>
+                <a:latin typeface="+mn-lt"/>
+              </a:rPr>
+              <a:t> </a:t>
+            </a:r>
+            <a:r>
+              <a:rPr lang="en-GB" b="1" dirty="0" err="1">
+                <a:effectLst/>
+                <a:latin typeface="+mn-lt"/>
+              </a:rPr>
+              <a:t>tọa</a:t>
+            </a:r>
+            <a:r>
+              <a:rPr lang="en-GB" b="1" dirty="0">
+                <a:effectLst/>
+                <a:latin typeface="+mn-lt"/>
+              </a:rPr>
+              <a:t> </a:t>
+            </a:r>
+            <a:r>
+              <a:rPr lang="en-GB" b="1" dirty="0" err="1">
+                <a:effectLst/>
+                <a:latin typeface="+mn-lt"/>
+              </a:rPr>
+              <a:t>độ</a:t>
+            </a:r>
+            <a:r>
+              <a:rPr lang="en-GB" b="1" dirty="0">
+                <a:effectLst/>
+                <a:latin typeface="+mn-lt"/>
+              </a:rPr>
+              <a:t> </a:t>
+            </a:r>
+            <a:r>
+              <a:rPr lang="en-GB" b="1" dirty="0" err="1">
+                <a:effectLst/>
+                <a:latin typeface="+mn-lt"/>
+              </a:rPr>
+              <a:t>để</a:t>
+            </a:r>
+            <a:r>
+              <a:rPr lang="en-GB" b="1" dirty="0">
+                <a:effectLst/>
+                <a:latin typeface="+mn-lt"/>
+              </a:rPr>
+              <a:t> </a:t>
+            </a:r>
+            <a:r>
+              <a:rPr lang="en-GB" b="1" dirty="0" err="1">
+                <a:effectLst/>
+                <a:latin typeface="+mn-lt"/>
+              </a:rPr>
+              <a:t>tạo</a:t>
+            </a:r>
+            <a:r>
+              <a:rPr lang="en-GB" b="1" dirty="0">
+                <a:effectLst/>
+                <a:latin typeface="+mn-lt"/>
+              </a:rPr>
+              <a:t> </a:t>
+            </a:r>
+            <a:r>
+              <a:rPr lang="en-GB" b="1" dirty="0" err="1">
+                <a:effectLst/>
+                <a:latin typeface="+mn-lt"/>
+              </a:rPr>
+              <a:t>dữ</a:t>
+            </a:r>
+            <a:r>
+              <a:rPr lang="en-GB" b="1" dirty="0">
+                <a:effectLst/>
+                <a:latin typeface="+mn-lt"/>
+              </a:rPr>
+              <a:t> </a:t>
+            </a:r>
+            <a:r>
+              <a:rPr lang="en-GB" b="1" dirty="0" err="1">
+                <a:effectLst/>
+                <a:latin typeface="+mn-lt"/>
+              </a:rPr>
+              <a:t>liệu</a:t>
+            </a:r>
+            <a:r>
+              <a:rPr lang="en-GB" b="1" dirty="0">
+                <a:effectLst/>
+                <a:latin typeface="+mn-lt"/>
+              </a:rPr>
+              <a:t> di </a:t>
+            </a:r>
+            <a:r>
+              <a:rPr lang="en-GB" b="1" dirty="0" err="1">
+                <a:effectLst/>
+                <a:latin typeface="+mn-lt"/>
+              </a:rPr>
+              <a:t>chuyển</a:t>
+            </a:r>
+            <a:r>
+              <a:rPr lang="en-GB" b="1" dirty="0">
+                <a:effectLst/>
+                <a:latin typeface="+mn-lt"/>
+              </a:rPr>
+              <a:t> </a:t>
+            </a:r>
+            <a:r>
+              <a:rPr lang="en-GB" b="1" dirty="0" err="1">
+                <a:effectLst/>
+                <a:latin typeface="+mn-lt"/>
+              </a:rPr>
+              <a:t>thực</a:t>
+            </a:r>
+            <a:r>
+              <a:rPr lang="en-GB" b="1" dirty="0">
+                <a:effectLst/>
+                <a:latin typeface="+mn-lt"/>
+              </a:rPr>
+              <a:t> </a:t>
+            </a:r>
+            <a:r>
+              <a:rPr lang="en-GB" b="1" dirty="0" err="1">
+                <a:effectLst/>
+                <a:latin typeface="+mn-lt"/>
+              </a:rPr>
+              <a:t>tế</a:t>
+            </a:r>
+            <a:r>
+              <a:rPr lang="en-GB" b="1" dirty="0">
+                <a:effectLst/>
+                <a:latin typeface="+mn-lt"/>
+              </a:rPr>
+              <a:t> (Ground Truth/Simulation)</a:t>
+            </a:r>
+            <a:r>
+              <a:rPr lang="en-GB" dirty="0">
+                <a:effectLst/>
+                <a:latin typeface="+mn-lt"/>
+              </a:rPr>
+              <a:t>.</a:t>
+            </a:r>
+            <a:r>
+              <a:rPr lang="en-GB" dirty="0"/>
+              <a:t> </a:t>
+            </a:r>
+          </a:p>
+        </p:txBody>
+      </p:sp>
+      <p:sp>
+        <p:nvSpPr>
+          <p:cNvPr id="14" name="Arrow: Right 13">
+            <a:extLst>
+              <a:ext uri="{FF2B5EF4-FFF2-40B4-BE49-F238E27FC236}">
+                <a16:creationId xmlns:a16="http://schemas.microsoft.com/office/drawing/2014/main" id="{803B0E77-8DC6-245C-6D82-F1FA6C0F2E5B}"/>
+              </a:ext>
+            </a:extLst>
+          </p:cNvPr>
+          <p:cNvSpPr/>
+          <p:nvPr/>
+        </p:nvSpPr>
+        <p:spPr>
+          <a:xfrm>
+            <a:off x="2778100" y="5354398"/>
+            <a:ext cx="978408" cy="484632"/>
+          </a:xfrm>
+          <a:prstGeom prst="rightArrow">
+            <a:avLst/>
+          </a:prstGeom>
+        </p:spPr>
+        <p:style>
+          <a:lnRef idx="2">
+            <a:schemeClr val="accent1">
+              <a:shade val="15000"/>
+            </a:schemeClr>
+          </a:lnRef>
+          <a:fillRef idx="1">
+            <a:schemeClr val="accent1"/>
+          </a:fillRef>
+          <a:effectRef idx="0">
+            <a:schemeClr val="accent1"/>
+          </a:effectRef>
+          <a:fontRef idx="minor">
+            <a:schemeClr val="lt1"/>
+          </a:fontRef>
+        </p:style>
+        <p:txBody>
+          <a:bodyPr rtlCol="0" anchor="ctr"/>
+          <a:lstStyle/>
+          <a:p>
+            <a:pPr algn="ctr"/>
+            <a:endParaRPr lang="en-GB"/>
+          </a:p>
+        </p:txBody>
+      </p:sp>
+      <p:sp>
+        <p:nvSpPr>
+          <p:cNvPr id="15" name="TextBox 14">
+            <a:extLst>
+              <a:ext uri="{FF2B5EF4-FFF2-40B4-BE49-F238E27FC236}">
+                <a16:creationId xmlns:a16="http://schemas.microsoft.com/office/drawing/2014/main" id="{23271E27-2A7F-624D-B602-F0DD75CF8203}"/>
+              </a:ext>
+            </a:extLst>
+          </p:cNvPr>
+          <p:cNvSpPr txBox="1"/>
+          <p:nvPr/>
+        </p:nvSpPr>
+        <p:spPr>
+          <a:xfrm>
+            <a:off x="3891761" y="5396659"/>
+            <a:ext cx="1609736" cy="400110"/>
+          </a:xfrm>
+          <a:prstGeom prst="rect">
+            <a:avLst/>
+          </a:prstGeom>
+          <a:noFill/>
+        </p:spPr>
+        <p:txBody>
+          <a:bodyPr wrap="none" rtlCol="0">
+            <a:spAutoFit/>
+          </a:bodyPr>
+          <a:lstStyle/>
+          <a:p>
+            <a:r>
+              <a:rPr lang="vi-VN" sz="2000" dirty="0"/>
+              <a:t>THÓI QUEN</a:t>
+            </a:r>
+            <a:endParaRPr lang="en-GB" sz="2000" dirty="0"/>
+          </a:p>
+        </p:txBody>
+      </p:sp>
+      <p:sp>
+        <p:nvSpPr>
+          <p:cNvPr id="17" name="Arrow: Right 16">
+            <a:extLst>
+              <a:ext uri="{FF2B5EF4-FFF2-40B4-BE49-F238E27FC236}">
+                <a16:creationId xmlns:a16="http://schemas.microsoft.com/office/drawing/2014/main" id="{12A2BC87-CDB7-FE7D-F476-5A02CEB88DF5}"/>
+              </a:ext>
+            </a:extLst>
+          </p:cNvPr>
+          <p:cNvSpPr/>
+          <p:nvPr/>
+        </p:nvSpPr>
+        <p:spPr>
+          <a:xfrm>
+            <a:off x="5774729" y="5365001"/>
+            <a:ext cx="978408" cy="484632"/>
+          </a:xfrm>
+          <a:prstGeom prst="rightArrow">
+            <a:avLst/>
+          </a:prstGeom>
+        </p:spPr>
+        <p:style>
+          <a:lnRef idx="2">
+            <a:schemeClr val="accent1">
+              <a:shade val="15000"/>
+            </a:schemeClr>
+          </a:lnRef>
+          <a:fillRef idx="1">
+            <a:schemeClr val="accent1"/>
+          </a:fillRef>
+          <a:effectRef idx="0">
+            <a:schemeClr val="accent1"/>
+          </a:effectRef>
+          <a:fontRef idx="minor">
+            <a:schemeClr val="lt1"/>
+          </a:fontRef>
+        </p:style>
+        <p:txBody>
+          <a:bodyPr rtlCol="0" anchor="ctr"/>
+          <a:lstStyle/>
+          <a:p>
+            <a:pPr algn="ctr"/>
+            <a:endParaRPr lang="en-GB"/>
+          </a:p>
+        </p:txBody>
+      </p:sp>
+      <p:sp>
+        <p:nvSpPr>
+          <p:cNvPr id="18" name="TextBox 17">
+            <a:extLst>
+              <a:ext uri="{FF2B5EF4-FFF2-40B4-BE49-F238E27FC236}">
+                <a16:creationId xmlns:a16="http://schemas.microsoft.com/office/drawing/2014/main" id="{B1BB51A5-CC17-68FF-172F-5143F9E4810E}"/>
+              </a:ext>
+            </a:extLst>
+          </p:cNvPr>
+          <p:cNvSpPr txBox="1"/>
+          <p:nvPr/>
+        </p:nvSpPr>
+        <p:spPr>
+          <a:xfrm>
+            <a:off x="3698520" y="5973219"/>
+            <a:ext cx="2076209" cy="369332"/>
+          </a:xfrm>
+          <a:prstGeom prst="rect">
+            <a:avLst/>
+          </a:prstGeom>
+          <a:noFill/>
+        </p:spPr>
+        <p:txBody>
+          <a:bodyPr wrap="none" rtlCol="0">
+            <a:spAutoFit/>
+          </a:bodyPr>
+          <a:lstStyle/>
+          <a:p>
+            <a:r>
+              <a:rPr lang="vi-VN"/>
+              <a:t>Phù hợp với đa số</a:t>
+            </a:r>
+            <a:endParaRPr lang="en-GB" dirty="0"/>
+          </a:p>
+        </p:txBody>
+      </p:sp>
+    </p:spTree>
+    <p:extLst>
+      <p:ext uri="{BB962C8B-B14F-4D97-AF65-F5344CB8AC3E}">
+        <p14:creationId xmlns:p14="http://schemas.microsoft.com/office/powerpoint/2010/main" val="3117765397"/>
+      </p:ext>
+    </p:extLst>
+  </p:cSld>
+  <p:clrMapOvr>
+    <a:masterClrMapping/>
+  </p:clrMapOvr>
+</p:sld>
+</file>
+
+<file path=ppt/slides/slide14.xml><?xml version="1.0" encoding="utf-8"?>
+<p:sld xmlns:a="http://schemas.openxmlformats.org/drawingml/2006/main" xmlns:r="http://schemas.openxmlformats.org/officeDocument/2006/relationships" xmlns:p="http://schemas.openxmlformats.org/presentationml/2006/main">
+  <p:cSld>
+    <p:spTree>
+      <p:nvGrpSpPr>
+        <p:cNvPr id="1" name="">
+          <a:extLst>
+            <a:ext uri="{FF2B5EF4-FFF2-40B4-BE49-F238E27FC236}">
+              <a16:creationId xmlns:a16="http://schemas.microsoft.com/office/drawing/2014/main" id="{ACD2F627-F806-0C2C-964B-E6C03DEF9CD8}"/>
+            </a:ext>
+          </a:extLst>
+        </p:cNvPr>
+        <p:cNvGrpSpPr/>
+        <p:nvPr/>
+      </p:nvGrpSpPr>
+      <p:grpSpPr>
+        <a:xfrm>
+          <a:off x="0" y="0"/>
+          <a:ext cx="0" cy="0"/>
+          <a:chOff x="0" y="0"/>
+          <a:chExt cx="0" cy="0"/>
+        </a:xfrm>
+      </p:grpSpPr>
+      <p:pic>
+        <p:nvPicPr>
+          <p:cNvPr id="5" name="Picture 4">
+            <a:extLst>
+              <a:ext uri="{FF2B5EF4-FFF2-40B4-BE49-F238E27FC236}">
+                <a16:creationId xmlns:a16="http://schemas.microsoft.com/office/drawing/2014/main" id="{D4374ED2-925B-DE04-CCCF-B22DC2FAA8F9}"/>
+              </a:ext>
+            </a:extLst>
+          </p:cNvPr>
+          <p:cNvPicPr>
+            <a:picLocks noChangeAspect="1"/>
+          </p:cNvPicPr>
+          <p:nvPr/>
+        </p:nvPicPr>
+        <p:blipFill>
+          <a:blip r:embed="rId2"/>
+          <a:stretch>
+            <a:fillRect/>
+          </a:stretch>
+        </p:blipFill>
+        <p:spPr>
+          <a:xfrm>
+            <a:off x="0" y="-439987"/>
+            <a:ext cx="5550148" cy="7467701"/>
+          </a:xfrm>
+          <a:prstGeom prst="rect">
+            <a:avLst/>
+          </a:prstGeom>
+        </p:spPr>
+      </p:pic>
+      <p:pic>
+        <p:nvPicPr>
+          <p:cNvPr id="7" name="Picture 6">
+            <a:extLst>
+              <a:ext uri="{FF2B5EF4-FFF2-40B4-BE49-F238E27FC236}">
+                <a16:creationId xmlns:a16="http://schemas.microsoft.com/office/drawing/2014/main" id="{97115987-B958-02DA-FC67-3401D5CD793B}"/>
+              </a:ext>
+            </a:extLst>
+          </p:cNvPr>
+          <p:cNvPicPr>
+            <a:picLocks noChangeAspect="1"/>
+          </p:cNvPicPr>
+          <p:nvPr/>
+        </p:nvPicPr>
+        <p:blipFill>
+          <a:blip r:embed="rId3"/>
+          <a:stretch>
+            <a:fillRect/>
+          </a:stretch>
+        </p:blipFill>
+        <p:spPr>
+          <a:xfrm>
+            <a:off x="5550148" y="3261926"/>
+            <a:ext cx="6641852" cy="3710097"/>
+          </a:xfrm>
+          <a:prstGeom prst="rect">
+            <a:avLst/>
+          </a:prstGeom>
+        </p:spPr>
+      </p:pic>
+      <p:cxnSp>
+        <p:nvCxnSpPr>
+          <p:cNvPr id="6" name="Straight Arrow Connector 5">
+            <a:extLst>
+              <a:ext uri="{FF2B5EF4-FFF2-40B4-BE49-F238E27FC236}">
+                <a16:creationId xmlns:a16="http://schemas.microsoft.com/office/drawing/2014/main" id="{B4BE681D-98A6-A3F1-5D17-EFAD329CDF36}"/>
+              </a:ext>
+            </a:extLst>
+          </p:cNvPr>
+          <p:cNvCxnSpPr>
+            <a:cxnSpLocks/>
+          </p:cNvCxnSpPr>
+          <p:nvPr/>
+        </p:nvCxnSpPr>
+        <p:spPr>
+          <a:xfrm flipV="1">
+            <a:off x="3434235" y="1361130"/>
+            <a:ext cx="481631" cy="1528653"/>
+          </a:xfrm>
+          <a:prstGeom prst="straightConnector1">
+            <a:avLst/>
+          </a:prstGeom>
+          <a:ln w="19050" cap="flat" cmpd="sng" algn="ctr">
+            <a:solidFill>
+              <a:schemeClr val="accent2"/>
+            </a:solidFill>
+            <a:prstDash val="solid"/>
+            <a:round/>
+            <a:headEnd type="none" w="med" len="med"/>
+            <a:tailEnd type="arrow" w="med" len="med"/>
+          </a:ln>
+        </p:spPr>
+        <p:style>
+          <a:lnRef idx="0">
+            <a:scrgbClr r="0" g="0" b="0"/>
+          </a:lnRef>
+          <a:fillRef idx="0">
+            <a:scrgbClr r="0" g="0" b="0"/>
+          </a:fillRef>
+          <a:effectRef idx="0">
+            <a:scrgbClr r="0" g="0" b="0"/>
+          </a:effectRef>
+          <a:fontRef idx="minor">
+            <a:schemeClr val="tx1"/>
+          </a:fontRef>
+        </p:style>
+      </p:cxnSp>
+      <p:cxnSp>
+        <p:nvCxnSpPr>
+          <p:cNvPr id="10" name="Straight Arrow Connector 9">
+            <a:extLst>
+              <a:ext uri="{FF2B5EF4-FFF2-40B4-BE49-F238E27FC236}">
+                <a16:creationId xmlns:a16="http://schemas.microsoft.com/office/drawing/2014/main" id="{5FC0F87F-5C73-E486-C7CF-3DA84CD65C70}"/>
+              </a:ext>
+            </a:extLst>
+          </p:cNvPr>
+          <p:cNvCxnSpPr>
+            <a:cxnSpLocks/>
+          </p:cNvCxnSpPr>
+          <p:nvPr/>
+        </p:nvCxnSpPr>
+        <p:spPr>
+          <a:xfrm>
+            <a:off x="3434235" y="2889783"/>
+            <a:ext cx="544452" cy="539217"/>
+          </a:xfrm>
+          <a:prstGeom prst="straightConnector1">
+            <a:avLst/>
+          </a:prstGeom>
+          <a:ln w="19050" cap="flat" cmpd="sng" algn="ctr">
+            <a:solidFill>
+              <a:schemeClr val="accent2"/>
+            </a:solidFill>
+            <a:prstDash val="solid"/>
+            <a:round/>
+            <a:headEnd type="none" w="med" len="med"/>
+            <a:tailEnd type="arrow" w="med" len="med"/>
+          </a:ln>
+        </p:spPr>
+        <p:style>
+          <a:lnRef idx="0">
+            <a:scrgbClr r="0" g="0" b="0"/>
+          </a:lnRef>
+          <a:fillRef idx="0">
+            <a:scrgbClr r="0" g="0" b="0"/>
+          </a:fillRef>
+          <a:effectRef idx="0">
+            <a:scrgbClr r="0" g="0" b="0"/>
+          </a:effectRef>
+          <a:fontRef idx="minor">
+            <a:schemeClr val="tx1"/>
+          </a:fontRef>
+        </p:style>
+      </p:cxnSp>
+      <p:pic>
+        <p:nvPicPr>
+          <p:cNvPr id="3" name="Picture 2">
+            <a:extLst>
+              <a:ext uri="{FF2B5EF4-FFF2-40B4-BE49-F238E27FC236}">
+                <a16:creationId xmlns:a16="http://schemas.microsoft.com/office/drawing/2014/main" id="{1228E203-AC1F-9D81-85FA-29F473BEBA43}"/>
+              </a:ext>
+            </a:extLst>
+          </p:cNvPr>
+          <p:cNvPicPr>
+            <a:picLocks noChangeAspect="1"/>
+          </p:cNvPicPr>
+          <p:nvPr/>
+        </p:nvPicPr>
+        <p:blipFill>
+          <a:blip r:embed="rId4"/>
+          <a:stretch>
+            <a:fillRect/>
+          </a:stretch>
+        </p:blipFill>
+        <p:spPr>
+          <a:xfrm>
+            <a:off x="3843738" y="1242467"/>
+            <a:ext cx="3412820" cy="2186533"/>
+          </a:xfrm>
+          <a:prstGeom prst="roundRect">
+            <a:avLst>
+              <a:gd name="adj" fmla="val 16667"/>
+            </a:avLst>
+          </a:prstGeom>
+          <a:ln>
+            <a:noFill/>
+          </a:ln>
+          <a:effectLst>
+            <a:outerShdw blurRad="76200" dist="38100" dir="7800000" algn="tl" rotWithShape="0">
+              <a:srgbClr val="000000">
+                <a:alpha val="40000"/>
+              </a:srgbClr>
+            </a:outerShdw>
+          </a:effectLst>
+          <a:scene3d>
+            <a:camera prst="orthographicFront"/>
+            <a:lightRig rig="contrasting" dir="t">
+              <a:rot lat="0" lon="0" rev="4200000"/>
+            </a:lightRig>
+          </a:scene3d>
+          <a:sp3d prstMaterial="plastic">
+            <a:bevelT w="381000" h="114300" prst="relaxedInset"/>
+            <a:contourClr>
+              <a:srgbClr val="969696"/>
+            </a:contourClr>
+          </a:sp3d>
+        </p:spPr>
+      </p:pic>
+      <p:sp>
+        <p:nvSpPr>
+          <p:cNvPr id="11" name="TextBox 10">
+            <a:extLst>
+              <a:ext uri="{FF2B5EF4-FFF2-40B4-BE49-F238E27FC236}">
+                <a16:creationId xmlns:a16="http://schemas.microsoft.com/office/drawing/2014/main" id="{FD924C5A-467F-DD73-8CFB-E6F25DE5C3C9}"/>
+              </a:ext>
+            </a:extLst>
+          </p:cNvPr>
+          <p:cNvSpPr txBox="1"/>
+          <p:nvPr/>
+        </p:nvSpPr>
+        <p:spPr>
+          <a:xfrm>
+            <a:off x="7256558" y="335590"/>
+            <a:ext cx="4543034" cy="2385268"/>
+          </a:xfrm>
+          <a:prstGeom prst="rect">
+            <a:avLst/>
+          </a:prstGeom>
+          <a:noFill/>
+        </p:spPr>
+        <p:txBody>
+          <a:bodyPr wrap="square">
+            <a:spAutoFit/>
+          </a:bodyPr>
+          <a:lstStyle/>
+          <a:p>
+            <a:pPr marL="342900" marR="0" lvl="0" indent="-342900" algn="l">
+              <a:spcBef>
+                <a:spcPts val="300"/>
+              </a:spcBef>
+              <a:spcAft>
+                <a:spcPts val="300"/>
+              </a:spcAft>
+              <a:buFont typeface="Arial" panose="020B0604020202020204" pitchFamily="34" charset="0"/>
+              <a:buChar char="•"/>
+            </a:pPr>
+            <a:r>
+              <a:rPr lang="en-GB" sz="1800" b="0" i="0" dirty="0" err="1">
+                <a:solidFill>
+                  <a:schemeClr val="tx1"/>
+                </a:solidFill>
+                <a:effectLst/>
+                <a:latin typeface="+mn-lt"/>
+              </a:rPr>
+              <a:t>Đây</a:t>
+            </a:r>
+            <a:r>
+              <a:rPr lang="en-GB" sz="1800" b="0" i="0" dirty="0">
+                <a:solidFill>
+                  <a:schemeClr val="tx1"/>
+                </a:solidFill>
+                <a:effectLst/>
+                <a:latin typeface="+mn-lt"/>
+              </a:rPr>
+              <a:t> </a:t>
+            </a:r>
+            <a:r>
+              <a:rPr lang="en-GB" sz="1800" b="0" i="0" dirty="0" err="1">
+                <a:solidFill>
+                  <a:schemeClr val="tx1"/>
+                </a:solidFill>
+                <a:effectLst/>
+                <a:latin typeface="+mn-lt"/>
+              </a:rPr>
+              <a:t>chưa</a:t>
+            </a:r>
+            <a:r>
+              <a:rPr lang="en-GB" sz="1800" b="0" i="0" dirty="0">
+                <a:solidFill>
+                  <a:schemeClr val="tx1"/>
+                </a:solidFill>
+                <a:effectLst/>
+                <a:latin typeface="+mn-lt"/>
+              </a:rPr>
+              <a:t> </a:t>
+            </a:r>
+            <a:r>
+              <a:rPr lang="en-GB" sz="1800" b="0" i="0" dirty="0" err="1">
+                <a:solidFill>
+                  <a:schemeClr val="tx1"/>
+                </a:solidFill>
+                <a:effectLst/>
+                <a:latin typeface="+mn-lt"/>
+              </a:rPr>
+              <a:t>phải</a:t>
+            </a:r>
+            <a:r>
+              <a:rPr lang="en-GB" sz="1800" b="0" i="0" dirty="0">
+                <a:solidFill>
+                  <a:schemeClr val="tx1"/>
+                </a:solidFill>
+                <a:effectLst/>
+                <a:latin typeface="+mn-lt"/>
+              </a:rPr>
+              <a:t> RAG </a:t>
+            </a:r>
+            <a:r>
+              <a:rPr lang="en-GB" sz="1800" b="0" i="0" dirty="0" err="1">
+                <a:solidFill>
+                  <a:schemeClr val="tx1"/>
+                </a:solidFill>
+                <a:effectLst/>
+                <a:latin typeface="+mn-lt"/>
+              </a:rPr>
+              <a:t>tài</a:t>
+            </a:r>
+            <a:r>
+              <a:rPr lang="en-GB" sz="1800" b="0" i="0" dirty="0">
+                <a:solidFill>
+                  <a:schemeClr val="tx1"/>
+                </a:solidFill>
+                <a:effectLst/>
+                <a:latin typeface="+mn-lt"/>
+              </a:rPr>
+              <a:t> </a:t>
+            </a:r>
+            <a:r>
+              <a:rPr lang="en-GB" sz="1800" b="0" i="0" dirty="0" err="1">
+                <a:solidFill>
+                  <a:schemeClr val="tx1"/>
+                </a:solidFill>
+                <a:effectLst/>
+                <a:latin typeface="+mn-lt"/>
+              </a:rPr>
+              <a:t>liệu</a:t>
+            </a:r>
+            <a:r>
+              <a:rPr lang="en-GB" sz="1800" b="0" i="0" dirty="0">
+                <a:solidFill>
+                  <a:schemeClr val="tx1"/>
+                </a:solidFill>
+                <a:effectLst/>
+                <a:latin typeface="+mn-lt"/>
+              </a:rPr>
+              <a:t>: </a:t>
+            </a:r>
+            <a:r>
+              <a:rPr lang="en-GB" sz="1800" b="0" i="0" dirty="0" err="1">
+                <a:solidFill>
+                  <a:schemeClr val="tx1"/>
+                </a:solidFill>
+                <a:effectLst/>
+                <a:latin typeface="+mn-lt"/>
+              </a:rPr>
+              <a:t>không</a:t>
+            </a:r>
+            <a:r>
+              <a:rPr lang="en-GB" sz="1800" b="0" i="0" dirty="0">
+                <a:solidFill>
+                  <a:schemeClr val="tx1"/>
+                </a:solidFill>
+                <a:effectLst/>
+                <a:latin typeface="+mn-lt"/>
+              </a:rPr>
+              <a:t> </a:t>
+            </a:r>
+            <a:r>
+              <a:rPr lang="en-GB" sz="1800" b="0" i="0" dirty="0" err="1">
+                <a:solidFill>
+                  <a:schemeClr val="tx1"/>
+                </a:solidFill>
+                <a:effectLst/>
+                <a:latin typeface="+mn-lt"/>
+              </a:rPr>
+              <a:t>truy</a:t>
+            </a:r>
+            <a:r>
+              <a:rPr lang="en-GB" sz="1800" b="0" i="0" dirty="0">
+                <a:solidFill>
+                  <a:schemeClr val="tx1"/>
+                </a:solidFill>
+                <a:effectLst/>
+                <a:latin typeface="+mn-lt"/>
+              </a:rPr>
+              <a:t> </a:t>
+            </a:r>
+            <a:r>
+              <a:rPr lang="en-GB" sz="1800" b="0" i="0" dirty="0" err="1">
+                <a:solidFill>
+                  <a:schemeClr val="tx1"/>
+                </a:solidFill>
+                <a:effectLst/>
+                <a:latin typeface="+mn-lt"/>
+              </a:rPr>
+              <a:t>xuất</a:t>
+            </a:r>
+            <a:r>
+              <a:rPr lang="en-GB" sz="1800" b="0" i="0" dirty="0">
+                <a:solidFill>
+                  <a:schemeClr val="tx1"/>
+                </a:solidFill>
+                <a:effectLst/>
+                <a:latin typeface="+mn-lt"/>
+              </a:rPr>
+              <a:t> </a:t>
+            </a:r>
+            <a:r>
+              <a:rPr lang="en-GB" sz="1800" b="0" i="0" dirty="0" err="1">
+                <a:solidFill>
+                  <a:schemeClr val="tx1"/>
+                </a:solidFill>
+                <a:effectLst/>
+                <a:latin typeface="+mn-lt"/>
+              </a:rPr>
+              <a:t>đoạn</a:t>
+            </a:r>
+            <a:r>
+              <a:rPr lang="en-GB" sz="1800" b="0" i="0" dirty="0">
+                <a:solidFill>
+                  <a:schemeClr val="tx1"/>
+                </a:solidFill>
+                <a:effectLst/>
+                <a:latin typeface="+mn-lt"/>
+              </a:rPr>
+              <a:t> code/</a:t>
+            </a:r>
+            <a:r>
+              <a:rPr lang="en-GB" sz="1800" b="0" i="0" dirty="0" err="1">
+                <a:solidFill>
+                  <a:schemeClr val="tx1"/>
+                </a:solidFill>
+                <a:effectLst/>
+                <a:latin typeface="+mn-lt"/>
+              </a:rPr>
+              <a:t>tài</a:t>
+            </a:r>
+            <a:r>
+              <a:rPr lang="en-GB" sz="1800" b="0" i="0" dirty="0">
+                <a:solidFill>
+                  <a:schemeClr val="tx1"/>
+                </a:solidFill>
+                <a:effectLst/>
+                <a:latin typeface="+mn-lt"/>
+              </a:rPr>
+              <a:t> </a:t>
+            </a:r>
+            <a:r>
+              <a:rPr lang="en-GB" sz="1800" b="0" i="0" dirty="0" err="1">
+                <a:solidFill>
+                  <a:schemeClr val="tx1"/>
+                </a:solidFill>
+                <a:effectLst/>
+                <a:latin typeface="+mn-lt"/>
+              </a:rPr>
+              <a:t>liệu</a:t>
+            </a:r>
+            <a:r>
+              <a:rPr lang="en-GB" sz="1800" b="0" i="0" dirty="0">
+                <a:solidFill>
+                  <a:schemeClr val="tx1"/>
+                </a:solidFill>
+                <a:effectLst/>
+                <a:latin typeface="+mn-lt"/>
+              </a:rPr>
+              <a:t> </a:t>
+            </a:r>
+            <a:r>
+              <a:rPr lang="en-GB" sz="1800" b="0" i="0" dirty="0" err="1">
+                <a:solidFill>
+                  <a:schemeClr val="tx1"/>
+                </a:solidFill>
+                <a:effectLst/>
+                <a:latin typeface="+mn-lt"/>
+              </a:rPr>
+              <a:t>giải</a:t>
+            </a:r>
+            <a:r>
+              <a:rPr lang="en-GB" sz="1800" b="0" i="0" dirty="0">
+                <a:solidFill>
+                  <a:schemeClr val="tx1"/>
+                </a:solidFill>
+                <a:effectLst/>
+                <a:latin typeface="+mn-lt"/>
+              </a:rPr>
+              <a:t> </a:t>
+            </a:r>
+            <a:r>
+              <a:rPr lang="en-GB" sz="1800" b="0" i="0" dirty="0" err="1">
+                <a:solidFill>
+                  <a:schemeClr val="tx1"/>
+                </a:solidFill>
+                <a:effectLst/>
+                <a:latin typeface="+mn-lt"/>
+              </a:rPr>
+              <a:t>thích</a:t>
+            </a:r>
+            <a:r>
+              <a:rPr lang="en-GB" sz="1800" b="0" i="0" dirty="0">
+                <a:solidFill>
+                  <a:schemeClr val="tx1"/>
+                </a:solidFill>
+                <a:effectLst/>
+                <a:latin typeface="+mn-lt"/>
+              </a:rPr>
+              <a:t> </a:t>
+            </a:r>
+            <a:r>
+              <a:rPr lang="en-GB" sz="1800" b="0" i="0" dirty="0" err="1">
+                <a:solidFill>
+                  <a:schemeClr val="tx1"/>
+                </a:solidFill>
+                <a:effectLst/>
+                <a:latin typeface="+mn-lt"/>
+              </a:rPr>
+              <a:t>hệ</a:t>
+            </a:r>
+            <a:r>
+              <a:rPr lang="en-GB" sz="1800" b="0" i="0" dirty="0">
+                <a:solidFill>
+                  <a:schemeClr val="tx1"/>
+                </a:solidFill>
+                <a:effectLst/>
+                <a:latin typeface="+mn-lt"/>
+              </a:rPr>
+              <a:t> </a:t>
+            </a:r>
+            <a:r>
+              <a:rPr lang="en-GB" sz="1800" b="0" i="0" dirty="0" err="1">
+                <a:solidFill>
+                  <a:schemeClr val="tx1"/>
+                </a:solidFill>
+                <a:effectLst/>
+                <a:latin typeface="+mn-lt"/>
+              </a:rPr>
+              <a:t>thống</a:t>
+            </a:r>
+            <a:r>
+              <a:rPr lang="en-GB" sz="1800" b="0" i="0" dirty="0">
+                <a:solidFill>
+                  <a:schemeClr val="tx1"/>
+                </a:solidFill>
+                <a:effectLst/>
+                <a:latin typeface="+mn-lt"/>
+              </a:rPr>
+              <a:t> </a:t>
+            </a:r>
+            <a:r>
+              <a:rPr lang="en-GB" sz="1800" b="0" i="0" dirty="0" err="1">
+                <a:solidFill>
+                  <a:schemeClr val="tx1"/>
+                </a:solidFill>
+                <a:effectLst/>
+                <a:latin typeface="+mn-lt"/>
+              </a:rPr>
+              <a:t>và</a:t>
+            </a:r>
+            <a:r>
+              <a:rPr lang="en-GB" sz="1800" b="0" i="0" dirty="0">
+                <a:solidFill>
+                  <a:schemeClr val="tx1"/>
+                </a:solidFill>
+                <a:effectLst/>
+                <a:latin typeface="+mn-lt"/>
+              </a:rPr>
+              <a:t> </a:t>
+            </a:r>
+            <a:r>
+              <a:rPr lang="en-GB" sz="1800" b="0" i="0" dirty="0" err="1">
+                <a:solidFill>
+                  <a:schemeClr val="tx1"/>
+                </a:solidFill>
+                <a:effectLst/>
+                <a:latin typeface="+mn-lt"/>
+              </a:rPr>
+              <a:t>không</a:t>
+            </a:r>
+            <a:r>
+              <a:rPr lang="en-GB" sz="1800" b="0" i="0" dirty="0">
+                <a:solidFill>
+                  <a:schemeClr val="tx1"/>
+                </a:solidFill>
+                <a:effectLst/>
+                <a:latin typeface="+mn-lt"/>
+              </a:rPr>
+              <a:t> </a:t>
+            </a:r>
+            <a:r>
+              <a:rPr lang="en-GB" sz="1800" b="0" i="0" dirty="0" err="1">
+                <a:solidFill>
+                  <a:schemeClr val="tx1"/>
+                </a:solidFill>
+                <a:effectLst/>
+                <a:latin typeface="+mn-lt"/>
+              </a:rPr>
+              <a:t>đưa</a:t>
+            </a:r>
+            <a:r>
+              <a:rPr lang="en-GB" sz="1800" b="0" i="0" dirty="0">
+                <a:solidFill>
+                  <a:schemeClr val="tx1"/>
+                </a:solidFill>
+                <a:effectLst/>
+                <a:latin typeface="+mn-lt"/>
+              </a:rPr>
+              <a:t> </a:t>
+            </a:r>
+            <a:r>
+              <a:rPr lang="en-GB" sz="1800" b="0" i="0" dirty="0" err="1">
+                <a:solidFill>
+                  <a:schemeClr val="tx1"/>
+                </a:solidFill>
+                <a:effectLst/>
+                <a:latin typeface="+mn-lt"/>
+              </a:rPr>
+              <a:t>tài</a:t>
+            </a:r>
+            <a:r>
+              <a:rPr lang="en-GB" sz="1800" b="0" i="0" dirty="0">
+                <a:solidFill>
+                  <a:schemeClr val="tx1"/>
+                </a:solidFill>
+                <a:effectLst/>
+                <a:latin typeface="+mn-lt"/>
+              </a:rPr>
+              <a:t> </a:t>
+            </a:r>
+            <a:r>
+              <a:rPr lang="en-GB" sz="1800" b="0" i="0" dirty="0" err="1">
+                <a:solidFill>
+                  <a:schemeClr val="tx1"/>
+                </a:solidFill>
+                <a:effectLst/>
+                <a:latin typeface="+mn-lt"/>
+              </a:rPr>
+              <a:t>liệu</a:t>
+            </a:r>
+            <a:r>
+              <a:rPr lang="en-GB" sz="1800" b="0" i="0" dirty="0">
+                <a:solidFill>
+                  <a:schemeClr val="tx1"/>
+                </a:solidFill>
+                <a:effectLst/>
+                <a:latin typeface="+mn-lt"/>
+              </a:rPr>
+              <a:t> </a:t>
+            </a:r>
+            <a:r>
+              <a:rPr lang="en-GB" sz="1800" b="0" i="0" dirty="0" err="1">
+                <a:solidFill>
+                  <a:schemeClr val="tx1"/>
+                </a:solidFill>
+                <a:effectLst/>
+                <a:latin typeface="+mn-lt"/>
+              </a:rPr>
+              <a:t>tìm</a:t>
+            </a:r>
+            <a:r>
+              <a:rPr lang="en-GB" sz="1800" b="0" i="0" dirty="0">
+                <a:solidFill>
+                  <a:schemeClr val="tx1"/>
+                </a:solidFill>
+                <a:effectLst/>
+                <a:latin typeface="+mn-lt"/>
+              </a:rPr>
+              <a:t> </a:t>
+            </a:r>
+            <a:r>
+              <a:rPr lang="en-GB" sz="1800" b="0" i="0" dirty="0" err="1">
+                <a:solidFill>
+                  <a:schemeClr val="tx1"/>
+                </a:solidFill>
+                <a:effectLst/>
+                <a:latin typeface="+mn-lt"/>
+              </a:rPr>
+              <a:t>được</a:t>
+            </a:r>
+            <a:r>
+              <a:rPr lang="en-GB" sz="1800" b="0" i="0" dirty="0">
+                <a:solidFill>
+                  <a:schemeClr val="tx1"/>
+                </a:solidFill>
+                <a:effectLst/>
+                <a:latin typeface="+mn-lt"/>
+              </a:rPr>
+              <a:t> </a:t>
+            </a:r>
+            <a:r>
+              <a:rPr lang="en-GB" sz="1800" b="0" i="0" dirty="0" err="1">
+                <a:solidFill>
+                  <a:schemeClr val="tx1"/>
+                </a:solidFill>
+                <a:effectLst/>
+                <a:latin typeface="+mn-lt"/>
+              </a:rPr>
+              <a:t>làm</a:t>
+            </a:r>
+            <a:r>
+              <a:rPr lang="en-GB" sz="1800" b="0" i="0" dirty="0">
+                <a:solidFill>
+                  <a:schemeClr val="tx1"/>
+                </a:solidFill>
+                <a:effectLst/>
+                <a:latin typeface="+mn-lt"/>
+              </a:rPr>
+              <a:t> </a:t>
+            </a:r>
+            <a:r>
+              <a:rPr lang="en-GB" sz="1800" b="0" i="0" dirty="0" err="1">
+                <a:solidFill>
+                  <a:schemeClr val="tx1"/>
+                </a:solidFill>
+                <a:effectLst/>
+                <a:latin typeface="+mn-lt"/>
+              </a:rPr>
+              <a:t>ngữ</a:t>
+            </a:r>
+            <a:r>
+              <a:rPr lang="en-GB" sz="1800" b="0" i="0" dirty="0">
+                <a:solidFill>
+                  <a:schemeClr val="tx1"/>
+                </a:solidFill>
+                <a:effectLst/>
+                <a:latin typeface="+mn-lt"/>
+              </a:rPr>
+              <a:t> </a:t>
+            </a:r>
+            <a:r>
+              <a:rPr lang="en-GB" sz="1800" b="0" i="0" dirty="0" err="1">
+                <a:solidFill>
+                  <a:schemeClr val="tx1"/>
+                </a:solidFill>
+                <a:effectLst/>
+                <a:latin typeface="+mn-lt"/>
+              </a:rPr>
+              <a:t>cảnh</a:t>
+            </a:r>
+            <a:r>
+              <a:rPr lang="en-GB" sz="1800" b="0" i="0" dirty="0">
+                <a:solidFill>
+                  <a:schemeClr val="tx1"/>
+                </a:solidFill>
+                <a:effectLst/>
+                <a:latin typeface="+mn-lt"/>
+              </a:rPr>
+              <a:t> </a:t>
+            </a:r>
+            <a:r>
+              <a:rPr lang="en-GB" sz="1800" b="0" i="0" dirty="0" err="1">
+                <a:solidFill>
+                  <a:schemeClr val="tx1"/>
+                </a:solidFill>
+                <a:effectLst/>
+                <a:latin typeface="+mn-lt"/>
+              </a:rPr>
+              <a:t>cho</a:t>
+            </a:r>
+            <a:r>
+              <a:rPr lang="en-GB" sz="1800" b="0" i="0" dirty="0">
+                <a:solidFill>
+                  <a:schemeClr val="tx1"/>
+                </a:solidFill>
+                <a:effectLst/>
+                <a:latin typeface="+mn-lt"/>
+              </a:rPr>
+              <a:t> LLM.</a:t>
+            </a:r>
+          </a:p>
+          <a:p>
+            <a:pPr marL="342900" marR="0" lvl="0" indent="-342900" algn="l">
+              <a:spcBef>
+                <a:spcPts val="300"/>
+              </a:spcBef>
+              <a:spcAft>
+                <a:spcPts val="300"/>
+              </a:spcAft>
+              <a:buFont typeface="Arial" panose="020B0604020202020204" pitchFamily="34" charset="0"/>
+              <a:buChar char="•"/>
+            </a:pPr>
+            <a:r>
+              <a:rPr lang="en-GB" sz="1800" b="0" i="0" dirty="0">
+                <a:solidFill>
+                  <a:schemeClr val="tx1"/>
+                </a:solidFill>
+                <a:effectLst/>
+                <a:latin typeface="+mn-lt"/>
+              </a:rPr>
+              <a:t>Code </a:t>
+            </a:r>
+            <a:r>
+              <a:rPr lang="en-GB" sz="1800" b="0" i="0" dirty="0" err="1">
+                <a:solidFill>
+                  <a:schemeClr val="tx1"/>
+                </a:solidFill>
+                <a:effectLst/>
+                <a:latin typeface="+mn-lt"/>
+              </a:rPr>
+              <a:t>lấy</a:t>
+            </a:r>
+            <a:r>
+              <a:rPr lang="en-GB" sz="1800" b="0" i="0" dirty="0">
+                <a:solidFill>
+                  <a:schemeClr val="tx1"/>
+                </a:solidFill>
+                <a:effectLst/>
+                <a:latin typeface="+mn-lt"/>
+              </a:rPr>
+              <a:t> intent </a:t>
+            </a:r>
+            <a:r>
+              <a:rPr lang="en-GB" sz="1800" b="0" i="0" dirty="0" err="1">
+                <a:solidFill>
+                  <a:schemeClr val="tx1"/>
+                </a:solidFill>
+                <a:effectLst/>
+                <a:latin typeface="+mn-lt"/>
+              </a:rPr>
+              <a:t>gần</a:t>
+            </a:r>
+            <a:r>
+              <a:rPr lang="en-GB" sz="1800" b="0" i="0" dirty="0">
+                <a:solidFill>
+                  <a:schemeClr val="tx1"/>
+                </a:solidFill>
+                <a:effectLst/>
+                <a:latin typeface="+mn-lt"/>
+              </a:rPr>
+              <a:t> </a:t>
+            </a:r>
+            <a:r>
+              <a:rPr lang="en-GB" sz="1800" b="0" i="0" dirty="0" err="1">
+                <a:solidFill>
+                  <a:schemeClr val="tx1"/>
+                </a:solidFill>
+                <a:effectLst/>
+                <a:latin typeface="+mn-lt"/>
+              </a:rPr>
+              <a:t>nhất</a:t>
+            </a:r>
+            <a:r>
+              <a:rPr lang="en-GB" sz="1800" b="0" i="0" dirty="0">
+                <a:solidFill>
+                  <a:schemeClr val="tx1"/>
+                </a:solidFill>
+                <a:effectLst/>
+                <a:latin typeface="+mn-lt"/>
+              </a:rPr>
+              <a:t> </a:t>
+            </a:r>
+            <a:r>
+              <a:rPr lang="en-GB" sz="1800" b="0" i="0" dirty="0" err="1">
+                <a:solidFill>
+                  <a:schemeClr val="tx1"/>
+                </a:solidFill>
+                <a:effectLst/>
+                <a:latin typeface="+mn-lt"/>
+              </a:rPr>
+              <a:t>ngay</a:t>
+            </a:r>
+            <a:r>
+              <a:rPr lang="en-GB" sz="1800" b="0" i="0" dirty="0">
+                <a:solidFill>
+                  <a:schemeClr val="tx1"/>
+                </a:solidFill>
+                <a:effectLst/>
+                <a:latin typeface="+mn-lt"/>
+              </a:rPr>
+              <a:t> </a:t>
+            </a:r>
+            <a:r>
+              <a:rPr lang="en-GB" sz="1800" b="0" i="0" dirty="0" err="1">
+                <a:solidFill>
+                  <a:schemeClr val="tx1"/>
+                </a:solidFill>
+                <a:effectLst/>
+                <a:latin typeface="+mn-lt"/>
+              </a:rPr>
+              <a:t>cả</a:t>
+            </a:r>
+            <a:r>
+              <a:rPr lang="en-GB" sz="1800" b="0" i="0" dirty="0">
+                <a:solidFill>
+                  <a:schemeClr val="tx1"/>
+                </a:solidFill>
+                <a:effectLst/>
+                <a:latin typeface="+mn-lt"/>
+              </a:rPr>
+              <a:t> </a:t>
+            </a:r>
+            <a:r>
+              <a:rPr lang="en-GB" sz="1800" b="0" i="0" dirty="0" err="1">
+                <a:solidFill>
+                  <a:schemeClr val="tx1"/>
+                </a:solidFill>
+                <a:effectLst/>
+                <a:latin typeface="+mn-lt"/>
+              </a:rPr>
+              <a:t>khi</a:t>
+            </a:r>
+            <a:r>
+              <a:rPr lang="en-GB" sz="1800" b="0" i="0" dirty="0">
+                <a:solidFill>
+                  <a:schemeClr val="tx1"/>
+                </a:solidFill>
+                <a:effectLst/>
+                <a:latin typeface="+mn-lt"/>
+              </a:rPr>
+              <a:t> </a:t>
+            </a:r>
+            <a:r>
+              <a:rPr lang="en-GB" sz="1800" b="0" i="0" dirty="0" err="1">
+                <a:solidFill>
+                  <a:schemeClr val="tx1"/>
+                </a:solidFill>
+                <a:effectLst/>
+                <a:latin typeface="+mn-lt"/>
+              </a:rPr>
+              <a:t>câu</a:t>
+            </a:r>
+            <a:r>
+              <a:rPr lang="en-GB" sz="1800" b="0" i="0" dirty="0">
+                <a:solidFill>
+                  <a:schemeClr val="tx1"/>
+                </a:solidFill>
+                <a:effectLst/>
+                <a:latin typeface="+mn-lt"/>
+              </a:rPr>
+              <a:t> </a:t>
+            </a:r>
+            <a:r>
+              <a:rPr lang="en-GB" sz="1800" b="0" i="0" dirty="0" err="1">
+                <a:solidFill>
+                  <a:schemeClr val="tx1"/>
+                </a:solidFill>
+                <a:effectLst/>
+                <a:latin typeface="+mn-lt"/>
+              </a:rPr>
+              <a:t>hỏi</a:t>
+            </a:r>
+            <a:r>
+              <a:rPr lang="en-GB" sz="1800" b="0" i="0" dirty="0">
+                <a:solidFill>
+                  <a:schemeClr val="tx1"/>
+                </a:solidFill>
+                <a:effectLst/>
+                <a:latin typeface="+mn-lt"/>
+              </a:rPr>
+              <a:t> </a:t>
+            </a:r>
+            <a:r>
+              <a:rPr lang="en-GB" sz="1800" b="0" i="0" dirty="0" err="1">
+                <a:solidFill>
+                  <a:schemeClr val="tx1"/>
+                </a:solidFill>
+                <a:effectLst/>
+                <a:latin typeface="+mn-lt"/>
+              </a:rPr>
+              <a:t>lạ</a:t>
+            </a:r>
+            <a:r>
+              <a:rPr lang="en-GB" sz="1800" b="0" i="0" dirty="0">
+                <a:solidFill>
+                  <a:schemeClr val="tx1"/>
+                </a:solidFill>
+                <a:effectLst/>
+                <a:latin typeface="+mn-lt"/>
+              </a:rPr>
+              <a:t> </a:t>
+            </a:r>
+            <a:r>
+              <a:rPr lang="en-GB" sz="1800" b="0" i="0" dirty="0" err="1">
+                <a:solidFill>
+                  <a:schemeClr val="tx1"/>
+                </a:solidFill>
+                <a:effectLst/>
+                <a:latin typeface="+mn-lt"/>
+              </a:rPr>
+              <a:t>hoặc</a:t>
+            </a:r>
+            <a:r>
+              <a:rPr lang="en-GB" sz="1800" b="0" i="0" dirty="0">
+                <a:solidFill>
+                  <a:schemeClr val="tx1"/>
+                </a:solidFill>
+                <a:effectLst/>
+                <a:latin typeface="+mn-lt"/>
+              </a:rPr>
+              <a:t> </a:t>
+            </a:r>
+            <a:r>
+              <a:rPr lang="en-GB" sz="1800" b="0" i="0" dirty="0" err="1">
+                <a:solidFill>
+                  <a:schemeClr val="tx1"/>
+                </a:solidFill>
+                <a:effectLst/>
+                <a:latin typeface="+mn-lt"/>
+              </a:rPr>
+              <a:t>mơ</a:t>
+            </a:r>
+            <a:r>
+              <a:rPr lang="en-GB" sz="1800" b="0" i="0" dirty="0">
+                <a:solidFill>
+                  <a:schemeClr val="tx1"/>
+                </a:solidFill>
+                <a:effectLst/>
+                <a:latin typeface="+mn-lt"/>
+              </a:rPr>
+              <a:t> </a:t>
+            </a:r>
+            <a:r>
+              <a:rPr lang="en-GB" sz="1800" b="0" i="0" dirty="0" err="1">
+                <a:solidFill>
+                  <a:schemeClr val="tx1"/>
+                </a:solidFill>
+                <a:effectLst/>
+                <a:latin typeface="+mn-lt"/>
+              </a:rPr>
+              <a:t>hồ</a:t>
+            </a:r>
+            <a:r>
+              <a:rPr lang="en-GB" sz="1800" b="0" i="0" dirty="0">
+                <a:solidFill>
+                  <a:schemeClr val="tx1"/>
+                </a:solidFill>
+                <a:effectLst/>
+                <a:latin typeface="+mn-lt"/>
+              </a:rPr>
+              <a:t>; </a:t>
+            </a:r>
+            <a:r>
+              <a:rPr lang="en-GB" sz="1800" b="0" i="0" dirty="0" err="1">
+                <a:solidFill>
+                  <a:schemeClr val="tx1"/>
+                </a:solidFill>
+                <a:effectLst/>
+                <a:latin typeface="+mn-lt"/>
+              </a:rPr>
+              <a:t>điểm</a:t>
+            </a:r>
+            <a:r>
+              <a:rPr lang="en-GB" sz="1800" b="0" i="0" dirty="0">
+                <a:solidFill>
+                  <a:schemeClr val="tx1"/>
+                </a:solidFill>
+                <a:effectLst/>
+                <a:latin typeface="+mn-lt"/>
+              </a:rPr>
+              <a:t> </a:t>
+            </a:r>
+            <a:r>
+              <a:rPr lang="en-GB" sz="1800" b="0" i="0" dirty="0" err="1">
+                <a:solidFill>
+                  <a:schemeClr val="tx1"/>
+                </a:solidFill>
+                <a:effectLst/>
+                <a:latin typeface="+mn-lt"/>
+              </a:rPr>
+              <a:t>tương</a:t>
+            </a:r>
+            <a:r>
+              <a:rPr lang="en-GB" sz="1800" b="0" i="0" dirty="0">
+                <a:solidFill>
+                  <a:schemeClr val="tx1"/>
+                </a:solidFill>
+                <a:effectLst/>
+                <a:latin typeface="+mn-lt"/>
+              </a:rPr>
+              <a:t> </a:t>
+            </a:r>
+            <a:r>
+              <a:rPr lang="en-GB" sz="1800" b="0" i="0" dirty="0" err="1">
+                <a:solidFill>
+                  <a:schemeClr val="tx1"/>
+                </a:solidFill>
+                <a:effectLst/>
+                <a:latin typeface="+mn-lt"/>
+              </a:rPr>
+              <a:t>đồng</a:t>
+            </a:r>
+            <a:r>
+              <a:rPr lang="en-GB" sz="1800" b="0" i="0" dirty="0">
+                <a:solidFill>
+                  <a:schemeClr val="tx1"/>
+                </a:solidFill>
+                <a:effectLst/>
+                <a:latin typeface="+mn-lt"/>
+              </a:rPr>
+              <a:t> </a:t>
+            </a:r>
+            <a:r>
+              <a:rPr lang="en-GB" sz="1800" b="0" i="0" dirty="0" err="1">
+                <a:solidFill>
+                  <a:schemeClr val="tx1"/>
+                </a:solidFill>
+                <a:effectLst/>
+                <a:latin typeface="+mn-lt"/>
+              </a:rPr>
+              <a:t>được</a:t>
+            </a:r>
+            <a:r>
+              <a:rPr lang="en-GB" sz="1800" b="0" i="0" dirty="0">
+                <a:solidFill>
+                  <a:schemeClr val="tx1"/>
+                </a:solidFill>
+                <a:effectLst/>
+                <a:latin typeface="+mn-lt"/>
+              </a:rPr>
+              <a:t> </a:t>
+            </a:r>
+            <a:r>
+              <a:rPr lang="en-GB" sz="1800" b="0" i="0" dirty="0" err="1">
+                <a:solidFill>
+                  <a:schemeClr val="tx1"/>
+                </a:solidFill>
+                <a:effectLst/>
+                <a:latin typeface="+mn-lt"/>
+              </a:rPr>
+              <a:t>tính</a:t>
+            </a:r>
+            <a:r>
+              <a:rPr lang="en-GB" sz="1800" b="0" i="0" dirty="0">
+                <a:solidFill>
+                  <a:schemeClr val="tx1"/>
+                </a:solidFill>
+                <a:effectLst/>
+                <a:latin typeface="+mn-lt"/>
+              </a:rPr>
+              <a:t> </a:t>
+            </a:r>
+            <a:r>
+              <a:rPr lang="en-GB" sz="1800" b="0" i="0" dirty="0" err="1">
+                <a:solidFill>
+                  <a:schemeClr val="tx1"/>
+                </a:solidFill>
+                <a:effectLst/>
+                <a:latin typeface="+mn-lt"/>
+              </a:rPr>
+              <a:t>nhưng</a:t>
+            </a:r>
+            <a:r>
+              <a:rPr lang="en-GB" sz="1800" b="0" i="0" dirty="0">
+                <a:solidFill>
+                  <a:schemeClr val="tx1"/>
+                </a:solidFill>
+                <a:effectLst/>
+                <a:latin typeface="+mn-lt"/>
+              </a:rPr>
+              <a:t> </a:t>
+            </a:r>
+            <a:r>
+              <a:rPr lang="en-GB" sz="1800" b="0" i="0" dirty="0" err="1">
+                <a:solidFill>
+                  <a:schemeClr val="tx1"/>
+                </a:solidFill>
+                <a:effectLst/>
+                <a:latin typeface="+mn-lt"/>
+              </a:rPr>
+              <a:t>không</a:t>
+            </a:r>
+            <a:r>
+              <a:rPr lang="en-GB" sz="1800" b="0" i="0" dirty="0">
+                <a:solidFill>
+                  <a:schemeClr val="tx1"/>
+                </a:solidFill>
+                <a:effectLst/>
+                <a:latin typeface="+mn-lt"/>
+              </a:rPr>
+              <a:t> </a:t>
+            </a:r>
+            <a:r>
+              <a:rPr lang="en-GB" sz="1800" b="0" i="0" dirty="0" err="1">
+                <a:solidFill>
+                  <a:schemeClr val="tx1"/>
+                </a:solidFill>
+                <a:effectLst/>
+                <a:latin typeface="+mn-lt"/>
+              </a:rPr>
+              <a:t>dùng</a:t>
+            </a:r>
+            <a:r>
+              <a:rPr lang="en-GB" sz="1800" b="0" i="0" dirty="0">
+                <a:solidFill>
+                  <a:schemeClr val="tx1"/>
+                </a:solidFill>
+                <a:effectLst/>
+                <a:latin typeface="+mn-lt"/>
+              </a:rPr>
+              <a:t> </a:t>
+            </a:r>
+            <a:r>
+              <a:rPr lang="en-GB" sz="1800" b="0" i="0" dirty="0" err="1">
+                <a:solidFill>
+                  <a:schemeClr val="tx1"/>
+                </a:solidFill>
+                <a:effectLst/>
+                <a:latin typeface="+mn-lt"/>
+              </a:rPr>
+              <a:t>để</a:t>
+            </a:r>
+            <a:r>
+              <a:rPr lang="en-GB" sz="1800" b="0" i="0" dirty="0">
+                <a:solidFill>
+                  <a:schemeClr val="tx1"/>
+                </a:solidFill>
+                <a:effectLst/>
+                <a:latin typeface="+mn-lt"/>
+              </a:rPr>
+              <a:t> </a:t>
+            </a:r>
+            <a:r>
+              <a:rPr lang="en-GB" sz="1800" b="0" i="0" dirty="0" err="1">
+                <a:solidFill>
+                  <a:schemeClr val="tx1"/>
+                </a:solidFill>
+                <a:effectLst/>
+                <a:latin typeface="+mn-lt"/>
+              </a:rPr>
+              <a:t>từ</a:t>
+            </a:r>
+            <a:r>
+              <a:rPr lang="en-GB" sz="1800" b="0" i="0" dirty="0">
+                <a:solidFill>
+                  <a:schemeClr val="tx1"/>
+                </a:solidFill>
+                <a:effectLst/>
+                <a:latin typeface="+mn-lt"/>
+              </a:rPr>
+              <a:t> </a:t>
+            </a:r>
+            <a:r>
+              <a:rPr lang="en-GB" sz="1800" b="0" i="0" dirty="0" err="1">
+                <a:solidFill>
+                  <a:schemeClr val="tx1"/>
+                </a:solidFill>
+                <a:effectLst/>
+                <a:latin typeface="+mn-lt"/>
+              </a:rPr>
+              <a:t>chối</a:t>
+            </a:r>
+            <a:r>
+              <a:rPr lang="en-GB" sz="1800" b="0" i="0" dirty="0">
+                <a:solidFill>
+                  <a:schemeClr val="tx1"/>
+                </a:solidFill>
+                <a:effectLst/>
+                <a:latin typeface="+mn-lt"/>
+              </a:rPr>
+              <a:t> </a:t>
+            </a:r>
+            <a:r>
+              <a:rPr lang="en-GB" sz="1800" b="0" i="0" dirty="0" err="1">
+                <a:solidFill>
+                  <a:schemeClr val="tx1"/>
+                </a:solidFill>
+                <a:effectLst/>
+                <a:latin typeface="+mn-lt"/>
+              </a:rPr>
+              <a:t>hoặc</a:t>
+            </a:r>
+            <a:r>
+              <a:rPr lang="en-GB" sz="1800" b="0" i="0" dirty="0">
+                <a:solidFill>
+                  <a:schemeClr val="tx1"/>
+                </a:solidFill>
+                <a:effectLst/>
+                <a:latin typeface="+mn-lt"/>
+              </a:rPr>
+              <a:t> </a:t>
+            </a:r>
+            <a:r>
+              <a:rPr lang="en-GB" sz="1800" b="0" i="0" dirty="0" err="1">
+                <a:solidFill>
+                  <a:schemeClr val="tx1"/>
+                </a:solidFill>
+                <a:effectLst/>
+                <a:latin typeface="+mn-lt"/>
+              </a:rPr>
+              <a:t>hỏi</a:t>
+            </a:r>
+            <a:r>
+              <a:rPr lang="en-GB" sz="1800" b="0" i="0" dirty="0">
+                <a:solidFill>
+                  <a:schemeClr val="tx1"/>
+                </a:solidFill>
+                <a:effectLst/>
+                <a:latin typeface="+mn-lt"/>
+              </a:rPr>
+              <a:t> </a:t>
+            </a:r>
+            <a:r>
+              <a:rPr lang="en-GB" sz="1800" b="0" i="0" dirty="0" err="1">
+                <a:solidFill>
+                  <a:schemeClr val="tx1"/>
+                </a:solidFill>
+                <a:effectLst/>
+                <a:latin typeface="+mn-lt"/>
+              </a:rPr>
+              <a:t>lại</a:t>
+            </a:r>
+            <a:r>
+              <a:rPr lang="en-GB" sz="1800" b="0" i="0" dirty="0">
+                <a:solidFill>
+                  <a:schemeClr val="tx1"/>
+                </a:solidFill>
+                <a:effectLst/>
+                <a:latin typeface="+mn-lt"/>
+              </a:rPr>
+              <a:t>.</a:t>
+            </a:r>
+            <a:endParaRPr lang="vi-VN" sz="1800" b="0" i="0" dirty="0">
+              <a:solidFill>
+                <a:schemeClr val="tx1"/>
+              </a:solidFill>
+              <a:effectLst/>
+              <a:latin typeface="+mn-lt"/>
+            </a:endParaRPr>
+          </a:p>
+        </p:txBody>
+      </p:sp>
+    </p:spTree>
+    <p:extLst>
+      <p:ext uri="{BB962C8B-B14F-4D97-AF65-F5344CB8AC3E}">
+        <p14:creationId xmlns:p14="http://schemas.microsoft.com/office/powerpoint/2010/main" val="2617008905"/>
+      </p:ext>
+    </p:extLst>
+  </p:cSld>
+  <p:clrMapOvr>
+    <a:masterClrMapping/>
+  </p:clrMapOvr>
+</p:sld>
+</file>
+
+<file path=ppt/slides/slide15.xml><?xml version="1.0" encoding="utf-8"?>
+<p:sld xmlns:a="http://schemas.openxmlformats.org/drawingml/2006/main" xmlns:r="http://schemas.openxmlformats.org/officeDocument/2006/relationships" xmlns:p="http://schemas.openxmlformats.org/presentationml/2006/main">
+  <p:cSld>
+    <p:spTree>
+      <p:nvGrpSpPr>
+        <p:cNvPr id="1" name="">
+          <a:extLst>
+            <a:ext uri="{FF2B5EF4-FFF2-40B4-BE49-F238E27FC236}">
+              <a16:creationId xmlns:a16="http://schemas.microsoft.com/office/drawing/2014/main" id="{3899B6E6-62E5-6AD9-57CB-7512E071D426}"/>
+            </a:ext>
+          </a:extLst>
+        </p:cNvPr>
+        <p:cNvGrpSpPr/>
+        <p:nvPr/>
+      </p:nvGrpSpPr>
+      <p:grpSpPr>
+        <a:xfrm>
+          <a:off x="0" y="0"/>
+          <a:ext cx="0" cy="0"/>
+          <a:chOff x="0" y="0"/>
+          <a:chExt cx="0" cy="0"/>
+        </a:xfrm>
+      </p:grpSpPr>
+      <p:sp>
+        <p:nvSpPr>
+          <p:cNvPr id="2" name="Title 1">
+            <a:extLst>
+              <a:ext uri="{FF2B5EF4-FFF2-40B4-BE49-F238E27FC236}">
+                <a16:creationId xmlns:a16="http://schemas.microsoft.com/office/drawing/2014/main" id="{AC6E80EF-9FB9-6902-85E2-09251E1D6BE4}"/>
+              </a:ext>
+            </a:extLst>
+          </p:cNvPr>
+          <p:cNvSpPr>
+            <a:spLocks noGrp="1"/>
+          </p:cNvSpPr>
+          <p:nvPr>
+            <p:ph type="title"/>
+          </p:nvPr>
+        </p:nvSpPr>
+        <p:spPr/>
+        <p:txBody>
+          <a:bodyPr/>
+          <a:lstStyle/>
+          <a:p>
+            <a:endParaRPr lang="en-GB"/>
+          </a:p>
+        </p:txBody>
+      </p:sp>
+      <p:pic>
+        <p:nvPicPr>
+          <p:cNvPr id="7" name="Content Placeholder 6">
+            <a:extLst>
+              <a:ext uri="{FF2B5EF4-FFF2-40B4-BE49-F238E27FC236}">
+                <a16:creationId xmlns:a16="http://schemas.microsoft.com/office/drawing/2014/main" id="{102654B3-E6BD-379C-F155-F9393129469A}"/>
+              </a:ext>
+            </a:extLst>
+          </p:cNvPr>
+          <p:cNvPicPr>
+            <a:picLocks noGrp="1" noChangeAspect="1"/>
+          </p:cNvPicPr>
+          <p:nvPr>
+            <p:ph idx="1"/>
+          </p:nvPr>
+        </p:nvPicPr>
+        <p:blipFill>
+          <a:blip r:embed="rId2"/>
+          <a:stretch>
+            <a:fillRect/>
+          </a:stretch>
+        </p:blipFill>
+        <p:spPr>
+          <a:xfrm>
+            <a:off x="0" y="5253925"/>
+            <a:ext cx="12435222" cy="1665432"/>
+          </a:xfrm>
+          <a:prstGeom prst="rect">
+            <a:avLst/>
+          </a:prstGeom>
+        </p:spPr>
+      </p:pic>
+      <p:pic>
+        <p:nvPicPr>
+          <p:cNvPr id="5" name="Picture 4">
+            <a:extLst>
+              <a:ext uri="{FF2B5EF4-FFF2-40B4-BE49-F238E27FC236}">
+                <a16:creationId xmlns:a16="http://schemas.microsoft.com/office/drawing/2014/main" id="{4FACCF27-FB4D-501D-3FF0-1575D75F516E}"/>
+              </a:ext>
+            </a:extLst>
+          </p:cNvPr>
+          <p:cNvPicPr>
+            <a:picLocks noChangeAspect="1"/>
+          </p:cNvPicPr>
+          <p:nvPr/>
+        </p:nvPicPr>
+        <p:blipFill>
+          <a:blip r:embed="rId3"/>
+          <a:stretch>
+            <a:fillRect/>
+          </a:stretch>
+        </p:blipFill>
+        <p:spPr>
+          <a:xfrm>
+            <a:off x="0" y="0"/>
+            <a:ext cx="12192000" cy="5253925"/>
+          </a:xfrm>
+          <a:prstGeom prst="rect">
+            <a:avLst/>
+          </a:prstGeom>
+        </p:spPr>
+      </p:pic>
+    </p:spTree>
+    <p:extLst>
+      <p:ext uri="{BB962C8B-B14F-4D97-AF65-F5344CB8AC3E}">
+        <p14:creationId xmlns:p14="http://schemas.microsoft.com/office/powerpoint/2010/main" val="2313997312"/>
+      </p:ext>
+    </p:extLst>
+  </p:cSld>
+  <p:clrMapOvr>
+    <a:masterClrMapping/>
+  </p:clrMapOvr>
+</p:sld>
+</file>
+
+<file path=ppt/slides/slide16.xml><?xml version="1.0" encoding="utf-8"?>
+<p:sld xmlns:a="http://schemas.openxmlformats.org/drawingml/2006/main" xmlns:r="http://schemas.openxmlformats.org/officeDocument/2006/relationships" xmlns:p="http://schemas.openxmlformats.org/presentationml/2006/main">
+  <p:cSld>
+    <p:spTree>
+      <p:nvGrpSpPr>
+        <p:cNvPr id="1" name="">
+          <a:extLst>
+            <a:ext uri="{FF2B5EF4-FFF2-40B4-BE49-F238E27FC236}">
+              <a16:creationId xmlns:a16="http://schemas.microsoft.com/office/drawing/2014/main" id="{139F98F9-A288-78B1-D0DC-364227DC472A}"/>
+            </a:ext>
+          </a:extLst>
+        </p:cNvPr>
+        <p:cNvGrpSpPr/>
+        <p:nvPr/>
+      </p:nvGrpSpPr>
+      <p:grpSpPr>
+        <a:xfrm>
+          <a:off x="0" y="0"/>
+          <a:ext cx="0" cy="0"/>
+          <a:chOff x="0" y="0"/>
+          <a:chExt cx="0" cy="0"/>
+        </a:xfrm>
+      </p:grpSpPr>
+      <p:pic>
+        <p:nvPicPr>
+          <p:cNvPr id="7" name="Picture 6">
+            <a:extLst>
+              <a:ext uri="{FF2B5EF4-FFF2-40B4-BE49-F238E27FC236}">
+                <a16:creationId xmlns:a16="http://schemas.microsoft.com/office/drawing/2014/main" id="{66CD6A39-A02C-D849-B139-D5D7ABDCED43}"/>
+              </a:ext>
+            </a:extLst>
+          </p:cNvPr>
+          <p:cNvPicPr>
+            <a:picLocks noChangeAspect="1"/>
+          </p:cNvPicPr>
+          <p:nvPr/>
+        </p:nvPicPr>
+        <p:blipFill>
+          <a:blip r:embed="rId2">
+            <a:extLst>
+              <a:ext uri="{28A0092B-C50C-407E-A947-70E740481C1C}">
+                <a14:useLocalDpi xmlns:a14="http://schemas.microsoft.com/office/drawing/2010/main" val="0"/>
+              </a:ext>
+            </a:extLst>
+          </a:blip>
+          <a:stretch>
+            <a:fillRect/>
+          </a:stretch>
+        </p:blipFill>
+        <p:spPr>
+          <a:xfrm>
+            <a:off x="6478" y="0"/>
+            <a:ext cx="12185522" cy="6858000"/>
+          </a:xfrm>
+          <a:prstGeom prst="rect">
+            <a:avLst/>
+          </a:prstGeom>
+        </p:spPr>
+      </p:pic>
+    </p:spTree>
+    <p:extLst>
+      <p:ext uri="{BB962C8B-B14F-4D97-AF65-F5344CB8AC3E}">
+        <p14:creationId xmlns:p14="http://schemas.microsoft.com/office/powerpoint/2010/main" val="1865523402"/>
+      </p:ext>
+    </p:extLst>
+  </p:cSld>
+  <p:clrMapOvr>
+    <a:masterClrMapping/>
+  </p:clrMapOvr>
+</p:sld>
+</file>
+
+<file path=ppt/slides/slide17.xml><?xml version="1.0" encoding="utf-8"?>
+<p:sld xmlns:a="http://schemas.openxmlformats.org/drawingml/2006/main" xmlns:r="http://schemas.openxmlformats.org/officeDocument/2006/relationships" xmlns:p="http://schemas.openxmlformats.org/presentationml/2006/main">
+  <p:cSld>
+    <p:spTree>
+      <p:nvGrpSpPr>
+        <p:cNvPr id="1" name="">
+          <a:extLst>
+            <a:ext uri="{FF2B5EF4-FFF2-40B4-BE49-F238E27FC236}">
+              <a16:creationId xmlns:a16="http://schemas.microsoft.com/office/drawing/2014/main" id="{975B5FB8-2726-A0CD-D649-766E420383D6}"/>
+            </a:ext>
+          </a:extLst>
+        </p:cNvPr>
+        <p:cNvGrpSpPr/>
+        <p:nvPr/>
+      </p:nvGrpSpPr>
+      <p:grpSpPr>
+        <a:xfrm>
+          <a:off x="0" y="0"/>
+          <a:ext cx="0" cy="0"/>
+          <a:chOff x="0" y="0"/>
+          <a:chExt cx="0" cy="0"/>
+        </a:xfrm>
+      </p:grpSpPr>
+      <p:sp>
+        <p:nvSpPr>
+          <p:cNvPr id="2" name="Title 1">
+            <a:extLst>
+              <a:ext uri="{FF2B5EF4-FFF2-40B4-BE49-F238E27FC236}">
+                <a16:creationId xmlns:a16="http://schemas.microsoft.com/office/drawing/2014/main" id="{5EFAF050-A34D-F372-E9E8-966F1D857A64}"/>
+              </a:ext>
+            </a:extLst>
+          </p:cNvPr>
+          <p:cNvSpPr>
+            <a:spLocks noGrp="1"/>
+          </p:cNvSpPr>
+          <p:nvPr>
+            <p:ph type="title"/>
+          </p:nvPr>
+        </p:nvSpPr>
+        <p:spPr/>
+        <p:txBody>
+          <a:bodyPr/>
+          <a:lstStyle/>
+          <a:p>
+            <a:endParaRPr lang="en-GB"/>
+          </a:p>
+        </p:txBody>
+      </p:sp>
+      <p:sp>
+        <p:nvSpPr>
+          <p:cNvPr id="3" name="Content Placeholder 2">
+            <a:extLst>
+              <a:ext uri="{FF2B5EF4-FFF2-40B4-BE49-F238E27FC236}">
+                <a16:creationId xmlns:a16="http://schemas.microsoft.com/office/drawing/2014/main" id="{A0800E5C-456B-1279-11D0-3F6D4B874340}"/>
+              </a:ext>
+            </a:extLst>
+          </p:cNvPr>
+          <p:cNvSpPr>
+            <a:spLocks noGrp="1"/>
+          </p:cNvSpPr>
+          <p:nvPr>
+            <p:ph idx="1"/>
+          </p:nvPr>
+        </p:nvSpPr>
+        <p:spPr/>
+        <p:txBody>
+          <a:bodyPr/>
+          <a:lstStyle/>
+          <a:p>
+            <a:endParaRPr lang="en-GB"/>
+          </a:p>
+        </p:txBody>
+      </p:sp>
+    </p:spTree>
+    <p:extLst>
+      <p:ext uri="{BB962C8B-B14F-4D97-AF65-F5344CB8AC3E}">
+        <p14:creationId xmlns:p14="http://schemas.microsoft.com/office/powerpoint/2010/main" val="4001379818"/>
+      </p:ext>
+    </p:extLst>
+  </p:cSld>
+  <p:clrMapOvr>
+    <a:masterClrMapping/>
+  </p:clrMapOvr>
+</p:sld>
+</file>
+
+<file path=ppt/slides/slide18.xml><?xml version="1.0" encoding="utf-8"?>
+<p:sld xmlns:a="http://schemas.openxmlformats.org/drawingml/2006/main" xmlns:r="http://schemas.openxmlformats.org/officeDocument/2006/relationships" xmlns:p="http://schemas.openxmlformats.org/presentationml/2006/main">
+  <p:cSld>
+    <p:spTree>
+      <p:nvGrpSpPr>
+        <p:cNvPr id="1" name="">
+          <a:extLst>
+            <a:ext uri="{FF2B5EF4-FFF2-40B4-BE49-F238E27FC236}">
+              <a16:creationId xmlns:a16="http://schemas.microsoft.com/office/drawing/2014/main" id="{0375A052-1EE8-8FCE-EA65-E76CFCC0CD0F}"/>
+            </a:ext>
+          </a:extLst>
+        </p:cNvPr>
+        <p:cNvGrpSpPr/>
+        <p:nvPr/>
+      </p:nvGrpSpPr>
+      <p:grpSpPr>
+        <a:xfrm>
+          <a:off x="0" y="0"/>
+          <a:ext cx="0" cy="0"/>
+          <a:chOff x="0" y="0"/>
+          <a:chExt cx="0" cy="0"/>
+        </a:xfrm>
+      </p:grpSpPr>
+      <p:sp>
+        <p:nvSpPr>
+          <p:cNvPr id="2" name="Title 1">
+            <a:extLst>
+              <a:ext uri="{FF2B5EF4-FFF2-40B4-BE49-F238E27FC236}">
+                <a16:creationId xmlns:a16="http://schemas.microsoft.com/office/drawing/2014/main" id="{D8F8803C-17B2-5E5A-5F9F-181D695318CD}"/>
+              </a:ext>
+            </a:extLst>
+          </p:cNvPr>
+          <p:cNvSpPr>
+            <a:spLocks noGrp="1"/>
+          </p:cNvSpPr>
+          <p:nvPr>
+            <p:ph type="title"/>
+          </p:nvPr>
+        </p:nvSpPr>
+        <p:spPr/>
+        <p:txBody>
+          <a:bodyPr/>
+          <a:lstStyle/>
+          <a:p>
+            <a:endParaRPr lang="en-GB"/>
+          </a:p>
+        </p:txBody>
+      </p:sp>
+      <p:sp>
+        <p:nvSpPr>
+          <p:cNvPr id="3" name="Content Placeholder 2">
+            <a:extLst>
+              <a:ext uri="{FF2B5EF4-FFF2-40B4-BE49-F238E27FC236}">
+                <a16:creationId xmlns:a16="http://schemas.microsoft.com/office/drawing/2014/main" id="{679ACD68-6047-CAAF-A1A2-2CE818499714}"/>
+              </a:ext>
+            </a:extLst>
+          </p:cNvPr>
+          <p:cNvSpPr>
+            <a:spLocks noGrp="1"/>
+          </p:cNvSpPr>
+          <p:nvPr>
+            <p:ph idx="1"/>
+          </p:nvPr>
+        </p:nvSpPr>
+        <p:spPr/>
+        <p:txBody>
+          <a:bodyPr/>
+          <a:lstStyle/>
+          <a:p>
+            <a:endParaRPr lang="en-GB"/>
+          </a:p>
+        </p:txBody>
+      </p:sp>
+    </p:spTree>
+    <p:extLst>
+      <p:ext uri="{BB962C8B-B14F-4D97-AF65-F5344CB8AC3E}">
+        <p14:creationId xmlns:p14="http://schemas.microsoft.com/office/powerpoint/2010/main" val="754831216"/>
       </p:ext>
     </p:extLst>
   </p:cSld>
@@ -4747,4 +8179,319 @@
     </a:ext>
   </a:extLst>
 </a:theme>
+</file>
+
+<file path=ppt/theme/theme2.xml><?xml version="1.0" encoding="utf-8"?>
+<a:theme xmlns:a="http://schemas.openxmlformats.org/drawingml/2006/main" name="Office Theme">
+  <a:themeElements>
+    <a:clrScheme name="Office">
+      <a:dk1>
+        <a:sysClr val="windowText" lastClr="000000"/>
+      </a:dk1>
+      <a:lt1>
+        <a:sysClr val="window" lastClr="FFFFFF"/>
+      </a:lt1>
+      <a:dk2>
+        <a:srgbClr val="0E2841"/>
+      </a:dk2>
+      <a:lt2>
+        <a:srgbClr val="E8E8E8"/>
+      </a:lt2>
+      <a:accent1>
+        <a:srgbClr val="156082"/>
+      </a:accent1>
+      <a:accent2>
+        <a:srgbClr val="E97132"/>
+      </a:accent2>
+      <a:accent3>
+        <a:srgbClr val="196B24"/>
+      </a:accent3>
+      <a:accent4>
+        <a:srgbClr val="0F9ED5"/>
+      </a:accent4>
+      <a:accent5>
+        <a:srgbClr val="A02B93"/>
+      </a:accent5>
+      <a:accent6>
+        <a:srgbClr val="4EA72E"/>
+      </a:accent6>
+      <a:hlink>
+        <a:srgbClr val="467886"/>
+      </a:hlink>
+      <a:folHlink>
+        <a:srgbClr val="96607D"/>
+      </a:folHlink>
+    </a:clrScheme>
+    <a:fontScheme name="Office">
+      <a:majorFont>
+        <a:latin typeface="Aptos Display" panose="02110004020202020204"/>
+        <a:ea typeface=""/>
+        <a:cs typeface=""/>
+        <a:font script="Jpan" typeface="游ゴシック Light"/>
+        <a:font script="Hang" typeface="맑은 고딕"/>
+        <a:font script="Hans" typeface="等线 Light"/>
+        <a:font script="Hant" typeface="新細明體"/>
+        <a:font script="Arab" typeface="Times New Roman"/>
+        <a:font script="Hebr" typeface="Times New Roman"/>
+        <a:font script="Thai" typeface="Angsana New"/>
+        <a:font script="Ethi" typeface="Nyala"/>
+        <a:font script="Beng" typeface="Vrinda"/>
+        <a:font script="Gujr" typeface="Shruti"/>
+        <a:font script="Khmr" typeface="MoolBoran"/>
+        <a:font script="Knda" typeface="Tunga"/>
+        <a:font script="Guru" typeface="Raavi"/>
+        <a:font script="Cans" typeface="Euphemia"/>
+        <a:font script="Cher" typeface="Plantagenet Cherokee"/>
+        <a:font script="Yiii" typeface="Microsoft Yi Baiti"/>
+        <a:font script="Tibt" typeface="Microsoft Himalaya"/>
+        <a:font script="Thaa" typeface="MV Boli"/>
+        <a:font script="Deva" typeface="Mangal"/>
+        <a:font script="Telu" typeface="Gautami"/>
+        <a:font script="Taml" typeface="Latha"/>
+        <a:font script="Syrc" typeface="Estrangelo Edessa"/>
+        <a:font script="Orya" typeface="Kalinga"/>
+        <a:font script="Mlym" typeface="Kartika"/>
+        <a:font script="Laoo" typeface="DokChampa"/>
+        <a:font script="Sinh" typeface="Iskoola Pota"/>
+        <a:font script="Mong" typeface="Mongolian Baiti"/>
+        <a:font script="Viet" typeface="Times New Roman"/>
+        <a:font script="Uigh" typeface="Microsoft Uighur"/>
+        <a:font script="Geor" typeface="Sylfaen"/>
+        <a:font script="Armn" typeface="Arial"/>
+        <a:font script="Bugi" typeface="Leelawadee UI"/>
+        <a:font script="Bopo" typeface="Microsoft JhengHei"/>
+        <a:font script="Java" typeface="Javanese Text"/>
+        <a:font script="Lisu" typeface="Segoe UI"/>
+        <a:font script="Mymr" typeface="Myanmar Text"/>
+        <a:font script="Nkoo" typeface="Ebrima"/>
+        <a:font script="Olck" typeface="Nirmala UI"/>
+        <a:font script="Osma" typeface="Ebrima"/>
+        <a:font script="Phag" typeface="Phagspa"/>
+        <a:font script="Syrn" typeface="Estrangelo Edessa"/>
+        <a:font script="Syrj" typeface="Estrangelo Edessa"/>
+        <a:font script="Syre" typeface="Estrangelo Edessa"/>
+        <a:font script="Sora" typeface="Nirmala UI"/>
+        <a:font script="Tale" typeface="Microsoft Tai Le"/>
+        <a:font script="Talu" typeface="Microsoft New Tai Lue"/>
+        <a:font script="Tfng" typeface="Ebrima"/>
+      </a:majorFont>
+      <a:minorFont>
+        <a:latin typeface="Aptos" panose="02110004020202020204"/>
+        <a:ea typeface=""/>
+        <a:cs typeface=""/>
+        <a:font script="Jpan" typeface="游ゴシック"/>
+        <a:font script="Hang" typeface="맑은 고딕"/>
+        <a:font script="Hans" typeface="等线"/>
+        <a:font script="Hant" typeface="新細明體"/>
+        <a:font script="Arab" typeface="Arial"/>
+        <a:font script="Hebr" typeface="Arial"/>
+        <a:font script="Thai" typeface="Cordia New"/>
+        <a:font script="Ethi" typeface="Nyala"/>
+        <a:font script="Beng" typeface="Vrinda"/>
+        <a:font script="Gujr" typeface="Shruti"/>
+        <a:font script="Khmr" typeface="DaunPenh"/>
+        <a:font script="Knda" typeface="Tunga"/>
+        <a:font script="Guru" typeface="Raavi"/>
+        <a:font script="Cans" typeface="Euphemia"/>
+        <a:font script="Cher" typeface="Plantagenet Cherokee"/>
+        <a:font script="Yiii" typeface="Microsoft Yi Baiti"/>
+        <a:font script="Tibt" typeface="Microsoft Himalaya"/>
+        <a:font script="Thaa" typeface="MV Boli"/>
+        <a:font script="Deva" typeface="Mangal"/>
+        <a:font script="Telu" typeface="Gautami"/>
+        <a:font script="Taml" typeface="Latha"/>
+        <a:font script="Syrc" typeface="Estrangelo Edessa"/>
+        <a:font script="Orya" typeface="Kalinga"/>
+        <a:font script="Mlym" typeface="Kartika"/>
+        <a:font script="Laoo" typeface="DokChampa"/>
+        <a:font script="Sinh" typeface="Iskoola Pota"/>
+        <a:font script="Mong" typeface="Mongolian Baiti"/>
+        <a:font script="Viet" typeface="Arial"/>
+        <a:font script="Uigh" typeface="Microsoft Uighur"/>
+        <a:font script="Geor" typeface="Sylfaen"/>
+        <a:font script="Armn" typeface="Arial"/>
+        <a:font script="Bugi" typeface="Leelawadee UI"/>
+        <a:font script="Bopo" typeface="Microsoft JhengHei"/>
+        <a:font script="Java" typeface="Javanese Text"/>
+        <a:font script="Lisu" typeface="Segoe UI"/>
+        <a:font script="Mymr" typeface="Myanmar Text"/>
+        <a:font script="Nkoo" typeface="Ebrima"/>
+        <a:font script="Olck" typeface="Nirmala UI"/>
+        <a:font script="Osma" typeface="Ebrima"/>
+        <a:font script="Phag" typeface="Phagspa"/>
+        <a:font script="Syrn" typeface="Estrangelo Edessa"/>
+        <a:font script="Syrj" typeface="Estrangelo Edessa"/>
+        <a:font script="Syre" typeface="Estrangelo Edessa"/>
+        <a:font script="Sora" typeface="Nirmala UI"/>
+        <a:font script="Tale" typeface="Microsoft Tai Le"/>
+        <a:font script="Talu" typeface="Microsoft New Tai Lue"/>
+        <a:font script="Tfng" typeface="Ebrima"/>
+      </a:minorFont>
+    </a:fontScheme>
+    <a:fmtScheme name="Office">
+      <a:fillStyleLst>
+        <a:solidFill>
+          <a:schemeClr val="phClr"/>
+        </a:solidFill>
+        <a:gradFill rotWithShape="1">
+          <a:gsLst>
+            <a:gs pos="0">
+              <a:schemeClr val="phClr">
+                <a:lumMod val="110000"/>
+                <a:satMod val="105000"/>
+                <a:tint val="67000"/>
+              </a:schemeClr>
+            </a:gs>
+            <a:gs pos="50000">
+              <a:schemeClr val="phClr">
+                <a:lumMod val="105000"/>
+                <a:satMod val="103000"/>
+                <a:tint val="73000"/>
+              </a:schemeClr>
+            </a:gs>
+            <a:gs pos="100000">
+              <a:schemeClr val="phClr">
+                <a:lumMod val="105000"/>
+                <a:satMod val="109000"/>
+                <a:tint val="81000"/>
+              </a:schemeClr>
+            </a:gs>
+          </a:gsLst>
+          <a:lin ang="5400000" scaled="0"/>
+        </a:gradFill>
+        <a:gradFill rotWithShape="1">
+          <a:gsLst>
+            <a:gs pos="0">
+              <a:schemeClr val="phClr">
+                <a:satMod val="103000"/>
+                <a:lumMod val="102000"/>
+                <a:tint val="94000"/>
+              </a:schemeClr>
+            </a:gs>
+            <a:gs pos="50000">
+              <a:schemeClr val="phClr">
+                <a:satMod val="110000"/>
+                <a:lumMod val="100000"/>
+                <a:shade val="100000"/>
+              </a:schemeClr>
+            </a:gs>
+            <a:gs pos="100000">
+              <a:schemeClr val="phClr">
+                <a:lumMod val="99000"/>
+                <a:satMod val="120000"/>
+                <a:shade val="78000"/>
+              </a:schemeClr>
+            </a:gs>
+          </a:gsLst>
+          <a:lin ang="5400000" scaled="0"/>
+        </a:gradFill>
+      </a:fillStyleLst>
+      <a:lnStyleLst>
+        <a:ln w="12700" cap="flat" cmpd="sng" algn="ctr">
+          <a:solidFill>
+            <a:schemeClr val="phClr"/>
+          </a:solidFill>
+          <a:prstDash val="solid"/>
+          <a:miter lim="800000"/>
+        </a:ln>
+        <a:ln w="19050" cap="flat" cmpd="sng" algn="ctr">
+          <a:solidFill>
+            <a:schemeClr val="phClr"/>
+          </a:solidFill>
+          <a:prstDash val="solid"/>
+          <a:miter lim="800000"/>
+        </a:ln>
+        <a:ln w="25400" cap="flat" cmpd="sng" algn="ctr">
+          <a:solidFill>
+            <a:schemeClr val="phClr"/>
+          </a:solidFill>
+          <a:prstDash val="solid"/>
+          <a:miter lim="800000"/>
+        </a:ln>
+      </a:lnStyleLst>
+      <a:effectStyleLst>
+        <a:effectStyle>
+          <a:effectLst/>
+        </a:effectStyle>
+        <a:effectStyle>
+          <a:effectLst/>
+        </a:effectStyle>
+        <a:effectStyle>
+          <a:effectLst>
+            <a:outerShdw blurRad="57150" dist="19050" dir="5400000" algn="ctr" rotWithShape="0">
+              <a:srgbClr val="000000">
+                <a:alpha val="63000"/>
+              </a:srgbClr>
+            </a:outerShdw>
+          </a:effectLst>
+        </a:effectStyle>
+      </a:effectStyleLst>
+      <a:bgFillStyleLst>
+        <a:solidFill>
+          <a:schemeClr val="phClr"/>
+        </a:solidFill>
+        <a:solidFill>
+          <a:schemeClr val="phClr">
+            <a:tint val="95000"/>
+            <a:satMod val="170000"/>
+          </a:schemeClr>
+        </a:solidFill>
+        <a:gradFill rotWithShape="1">
+          <a:gsLst>
+            <a:gs pos="0">
+              <a:schemeClr val="phClr">
+                <a:tint val="93000"/>
+                <a:satMod val="150000"/>
+                <a:shade val="98000"/>
+                <a:lumMod val="102000"/>
+              </a:schemeClr>
+            </a:gs>
+            <a:gs pos="50000">
+              <a:schemeClr val="phClr">
+                <a:tint val="98000"/>
+                <a:satMod val="130000"/>
+                <a:shade val="90000"/>
+                <a:lumMod val="103000"/>
+              </a:schemeClr>
+            </a:gs>
+            <a:gs pos="100000">
+              <a:schemeClr val="phClr">
+                <a:shade val="63000"/>
+                <a:satMod val="120000"/>
+              </a:schemeClr>
+            </a:gs>
+          </a:gsLst>
+          <a:lin ang="5400000" scaled="0"/>
+        </a:gradFill>
+      </a:bgFillStyleLst>
+    </a:fmtScheme>
+  </a:themeElements>
+  <a:objectDefaults>
+    <a:lnDef>
+      <a:spPr/>
+      <a:bodyPr/>
+      <a:lstStyle/>
+      <a:style>
+        <a:lnRef idx="2">
+          <a:schemeClr val="accent1"/>
+        </a:lnRef>
+        <a:fillRef idx="0">
+          <a:schemeClr val="accent1"/>
+        </a:fillRef>
+        <a:effectRef idx="1">
+          <a:schemeClr val="accent1"/>
+        </a:effectRef>
+        <a:fontRef idx="minor">
+          <a:schemeClr val="tx1"/>
+        </a:fontRef>
+      </a:style>
+    </a:lnDef>
+  </a:objectDefaults>
+  <a:extraClrSchemeLst/>
+  <a:extLst>
+    <a:ext uri="{05A4C25C-085E-4340-85A3-A5531E510DB2}">
+      <thm15:themeFamily xmlns:thm15="http://schemas.microsoft.com/office/thememl/2012/main" name="Office Theme" id="{2E142A2C-CD16-42D6-873A-C26D2A0506FA}" vid="{1BDDFF52-6CD6-40A5-AB3C-68EB2F1E4D0A}"/>
+    </a:ext>
+  </a:extLst>
+</a:theme>
 </file>
</xml_diff>